<commit_message>
PowerPoint-Vorlage v2 (Serifen-Fließtext, C-Logo, mitwachsende Boxen), CI-Regeln Folien aktualisiert, Tool casi_templates
Co-Authored-By: Claude Opus 5.5 <noreply@anthropic.com>
Claude-Session: https://claude.ai/code/session_013CPr38Ajq4U6Bb9Du7X7Xh
</commit_message>
<xml_diff>
--- a/vorlagen/CASI-Folien-Beispiel.pptx
+++ b/vorlagen/CASI-Folien-Beispiel.pptx
@@ -27,6 +27,11 @@
     <p:embeddedFont>
       <p:font typeface="PP Mori Semibold" pitchFamily="2" charset="0"/>
       <p:regular r:id="rIdCasiFont2"/>
+    </p:embeddedFont>
+    <p:embeddedFont>
+      <p:font typeface="IBM Plex Serif" pitchFamily="2" charset="0"/>
+      <p:regular r:id="rIdCasiFont3"/>
+      <p:italic r:id="rIdCasiFont4"/>
     </p:embeddedFont>
   </p:embeddedFontLst>
   <p:defaultTextStyle>
@@ -1251,133 +1256,9 @@
           <a:ln/>
         </p:spPr>
       </p:sp>
-      <p:sp>
-        <p:nvSpPr>
-          <p:cNvPr id="3" name="Text 1"/>
-          <p:cNvSpPr/>
-          <p:nvPr>
-            <p:ph idx="101" type="title" hasCustomPrompt="1"/>
-          </p:nvPr>
-        </p:nvSpPr>
-        <p:spPr>
-          <a:xfrm>
-            <a:off x="612648" y="2395728"/>
-            <a:ext cx="2980944" cy="2743200"/>
-          </a:xfrm>
-          <a:prstGeom prst="rect">
-            <a:avLst/>
-          </a:prstGeom>
-          <a:noFill/>
-          <a:ln/>
-        </p:spPr>
-        <p:txBody>
-          <a:bodyPr wrap="square" rtlCol="0"/>
-          <a:lstStyle>
-            <a:lvl1pPr algn="l" indent="0" marL="0">
-              <a:lnSpc>
-                <a:spcPct val="110000"/>
-              </a:lnSpc>
-              <a:buNone/>
-              <a:defRPr lang="en-US" sz="2400" dirty="0">
-                <a:solidFill>
-                  <a:srgbClr val="FFFFFF"/>
-                </a:solidFill>
-                <a:latin typeface="PP Mori Semibold" pitchFamily="34" charset="0"/>
-                <a:ea typeface="PP Mori Semibold" pitchFamily="34" charset="-122"/>
-                <a:cs typeface="PP Mori Semibold" pitchFamily="34" charset="-120"/>
-              </a:defRPr>
-            </a:lvl1pPr>
-          </a:lstStyle>
-          <a:p>
-            <a:pPr algn="l" indent="0" marL="0">
-              <a:lnSpc>
-                <a:spcPct val="110000"/>
-              </a:lnSpc>
-              <a:buNone/>
-            </a:pPr>
-            <a:r>
-              <a:rPr lang="en-US" sz="2400" dirty="0">
-                <a:solidFill>
-                  <a:srgbClr val="FFFFFF"/>
-                </a:solidFill>
-                <a:latin typeface="PP Mori Semibold" pitchFamily="34" charset="0"/>
-                <a:ea typeface="PP Mori Semibold" pitchFamily="34" charset="-122"/>
-                <a:cs typeface="PP Mori Semibold" pitchFamily="34" charset="-120"/>
-              </a:rPr>
-              <a:t>Schlusssatz</a:t>
-            </a:r>
-            <a:endParaRPr lang="en-US" sz="2400" dirty="0"/>
-          </a:p>
-        </p:txBody>
-      </p:sp>
-      <p:sp>
-        <p:nvSpPr>
-          <p:cNvPr id="4" name="Text 1"/>
-          <p:cNvSpPr/>
-          <p:nvPr>
-            <p:ph idx="102" type="body" hasCustomPrompt="1"/>
-          </p:nvPr>
-        </p:nvSpPr>
-        <p:spPr>
-          <a:xfrm>
-            <a:off x="4818888" y="2395728"/>
-            <a:ext cx="6760159" cy="2743200"/>
-          </a:xfrm>
-          <a:prstGeom prst="rect">
-            <a:avLst/>
-          </a:prstGeom>
-          <a:noFill/>
-          <a:ln/>
-        </p:spPr>
-        <p:txBody>
-          <a:bodyPr wrap="square" rtlCol="0"/>
-          <a:lstStyle>
-            <a:lvl1pPr algn="l" indent="0" marL="0">
-              <a:lnSpc>
-                <a:spcPct val="125000"/>
-              </a:lnSpc>
-              <a:spcAft>
-                <a:spcPts val="600"/>
-              </a:spcAft>
-              <a:buNone/>
-              <a:defRPr lang="en-US" sz="1200" dirty="0">
-                <a:solidFill>
-                  <a:srgbClr val="0E4D49"/>
-                </a:solidFill>
-                <a:latin typeface="PP Mori" pitchFamily="34" charset="0"/>
-                <a:ea typeface="PP Mori" pitchFamily="34" charset="-122"/>
-                <a:cs typeface="PP Mori" pitchFamily="34" charset="-120"/>
-              </a:defRPr>
-            </a:lvl1pPr>
-          </a:lstStyle>
-          <a:p>
-            <a:pPr algn="l" indent="0" marL="0">
-              <a:lnSpc>
-                <a:spcPct val="125000"/>
-              </a:lnSpc>
-              <a:spcAft>
-                <a:spcPts val="600"/>
-              </a:spcAft>
-              <a:buNone/>
-            </a:pPr>
-            <a:r>
-              <a:rPr lang="en-US" sz="1200" dirty="0">
-                <a:solidFill>
-                  <a:srgbClr val="0E4D49"/>
-                </a:solidFill>
-                <a:latin typeface="PP Mori" pitchFamily="34" charset="0"/>
-                <a:ea typeface="PP Mori" pitchFamily="34" charset="-122"/>
-                <a:cs typeface="PP Mori" pitchFamily="34" charset="-120"/>
-              </a:rPr>
-              <a:t>Kontakt</a:t>
-            </a:r>
-            <a:endParaRPr lang="en-US" sz="1200" dirty="0"/>
-          </a:p>
-        </p:txBody>
-      </p:sp>
       <p:pic>
         <p:nvPicPr>
-          <p:cNvPr id="5" name="Image 0" descr="Carbon Accounting Standards Initiative">    </p:cNvPr>
+          <p:cNvPr id="3" name="Image 0" descr="CASI">    </p:cNvPr>
           <p:cNvPicPr>
             <a:picLocks noChangeAspect="1"/>
           </p:cNvPicPr>
@@ -1391,14 +1272,132 @@
         </p:blipFill>
         <p:spPr>
           <a:xfrm>
-            <a:off x="4818888" y="6016752"/>
-            <a:ext cx="1855650" cy="384048"/>
+            <a:off x="612648" y="493776"/>
+            <a:ext cx="450952" cy="502920"/>
           </a:xfrm>
           <a:prstGeom prst="rect">
             <a:avLst/>
           </a:prstGeom>
         </p:spPr>
       </p:pic>
+      <p:sp>
+        <p:nvSpPr>
+          <p:cNvPr id="4" name="Text 1"/>
+          <p:cNvSpPr/>
+          <p:nvPr>
+            <p:ph idx="102" type="title" hasCustomPrompt="1"/>
+          </p:nvPr>
+        </p:nvSpPr>
+        <p:spPr>
+          <a:xfrm>
+            <a:off x="612648" y="2395728"/>
+            <a:ext cx="2980944" cy="2743200"/>
+          </a:xfrm>
+          <a:prstGeom prst="rect">
+            <a:avLst/>
+          </a:prstGeom>
+          <a:noFill/>
+          <a:ln/>
+        </p:spPr>
+        <p:txBody>
+          <a:bodyPr lIns="0" tIns="0" rIns="0" bIns="0" wrap="square" rtlCol="0"/>
+          <a:lstStyle>
+            <a:lvl1pPr algn="l" indent="0" marL="0">
+              <a:lnSpc>
+                <a:spcPct val="110000"/>
+              </a:lnSpc>
+              <a:buNone/>
+              <a:defRPr lang="en-US" sz="2400" dirty="0">
+                <a:solidFill>
+                  <a:srgbClr val="FFFFFF"/>
+                </a:solidFill>
+                <a:latin typeface="PP Mori Semibold" pitchFamily="34" charset="0"/>
+                <a:ea typeface="PP Mori Semibold" pitchFamily="34" charset="-122"/>
+                <a:cs typeface="PP Mori Semibold" pitchFamily="34" charset="-120"/>
+              </a:defRPr>
+            </a:lvl1pPr>
+          </a:lstStyle>
+          <a:p>
+            <a:pPr algn="l" indent="0" marL="0">
+              <a:lnSpc>
+                <a:spcPct val="110000"/>
+              </a:lnSpc>
+              <a:buNone/>
+            </a:pPr>
+            <a:r>
+              <a:rPr lang="en-US" sz="2400" dirty="0">
+                <a:solidFill>
+                  <a:srgbClr val="FFFFFF"/>
+                </a:solidFill>
+                <a:latin typeface="PP Mori Semibold" pitchFamily="34" charset="0"/>
+                <a:ea typeface="PP Mori Semibold" pitchFamily="34" charset="-122"/>
+                <a:cs typeface="PP Mori Semibold" pitchFamily="34" charset="-120"/>
+              </a:rPr>
+              <a:t>Schlusssatz</a:t>
+            </a:r>
+            <a:endParaRPr lang="en-US" sz="2400" dirty="0"/>
+          </a:p>
+        </p:txBody>
+      </p:sp>
+      <p:sp>
+        <p:nvSpPr>
+          <p:cNvPr id="5" name="Text 1"/>
+          <p:cNvSpPr/>
+          <p:nvPr>
+            <p:ph idx="103" type="body" hasCustomPrompt="1"/>
+          </p:nvPr>
+        </p:nvSpPr>
+        <p:spPr>
+          <a:xfrm>
+            <a:off x="4818888" y="2395728"/>
+            <a:ext cx="6760159" cy="2743200"/>
+          </a:xfrm>
+          <a:prstGeom prst="rect">
+            <a:avLst/>
+          </a:prstGeom>
+          <a:noFill/>
+          <a:ln/>
+        </p:spPr>
+        <p:txBody>
+          <a:bodyPr lIns="0" tIns="0" rIns="0" bIns="0" wrap="square" rtlCol="0"/>
+          <a:lstStyle>
+            <a:lvl1pPr algn="l" indent="0" marL="0">
+              <a:lnSpc>
+                <a:spcPct val="135000"/>
+              </a:lnSpc>
+              <a:buNone/>
+              <a:defRPr lang="en-US" sz="1200" dirty="0">
+                <a:solidFill>
+                  <a:srgbClr val="0E4D49"/>
+                </a:solidFill>
+                <a:latin typeface="PP Mori" pitchFamily="34" charset="0"/>
+                <a:ea typeface="PP Mori" pitchFamily="34" charset="-122"/>
+                <a:cs typeface="PP Mori" pitchFamily="34" charset="-120"/>
+              </a:defRPr>
+            </a:lvl1pPr>
+          </a:lstStyle>
+          <a:p>
+            <a:pPr algn="l" indent="0" marL="0">
+              <a:lnSpc>
+                <a:spcPct val="135000"/>
+              </a:lnSpc>
+              <a:buNone/>
+            </a:pPr>
+            <a:r>
+              <a:rPr lang="en-US" sz="1200" dirty="0">
+                <a:solidFill>
+                  <a:srgbClr val="0E4D49"/>
+                </a:solidFill>
+                <a:latin typeface="PP Mori" pitchFamily="34" charset="0"/>
+                <a:ea typeface="PP Mori" pitchFamily="34" charset="-122"/>
+                <a:cs typeface="PP Mori" pitchFamily="34" charset="-120"/>
+              </a:rPr>
+              <a:t>Kontakt</a:t>
+            </a:r>
+            <a:endParaRPr lang="en-US" sz="1200" dirty="0"/>
+          </a:p>
+        </p:txBody>
+      </p:sp>
     </p:spTree>
   </p:cSld>
   <p:clrMapOvr>
@@ -1431,6 +1430,30 @@
           <a:chExt cx="0" cy="0"/>
         </a:xfrm>
       </p:grpSpPr>
+      <p:pic>
+        <p:nvPicPr>
+          <p:cNvPr id="2" name="Image 0" descr="CASI">    </p:cNvPr>
+          <p:cNvPicPr>
+            <a:picLocks noChangeAspect="1"/>
+          </p:cNvPicPr>
+          <p:nvPr/>
+        </p:nvPicPr>
+        <p:blipFill>
+          <a:blip r:embed="rId1"/>
+          <a:stretch>
+            <a:fillRect/>
+          </a:stretch>
+        </p:blipFill>
+        <p:spPr>
+          <a:xfrm>
+            <a:off x="612648" y="6437376"/>
+            <a:ext cx="163982" cy="182880"/>
+          </a:xfrm>
+          <a:prstGeom prst="rect">
+            <a:avLst/>
+          </a:prstGeom>
+        </p:spPr>
+      </p:pic>
       <p:sp>
         <p:nvSpPr>
           <p:cNvPr id="25" name="Slide Number Placeholder 0"/>
@@ -1513,7 +1536,7 @@
       </p:grpSpPr>
       <p:pic>
         <p:nvPicPr>
-          <p:cNvPr id="2" name="Image 0" descr="Carbon Accounting Standards Initiative">    </p:cNvPr>
+          <p:cNvPr id="2" name="Image 0" descr="CASI">    </p:cNvPr>
           <p:cNvPicPr>
             <a:picLocks noChangeAspect="1"/>
           </p:cNvPicPr>
@@ -1528,7 +1551,7 @@
         <p:spPr>
           <a:xfrm>
             <a:off x="612648" y="493776"/>
-            <a:ext cx="1855650" cy="384048"/>
+            <a:ext cx="450952" cy="502920"/>
           </a:xfrm>
           <a:prstGeom prst="rect">
             <a:avLst/>
@@ -1555,15 +1578,12 @@
           <a:ln/>
         </p:spPr>
         <p:txBody>
-          <a:bodyPr wrap="square" rtlCol="0"/>
+          <a:bodyPr lIns="0" tIns="0" rIns="0" bIns="0" wrap="square" rtlCol="0"/>
           <a:lstStyle>
             <a:lvl1pPr algn="l" indent="0" marL="0">
               <a:lnSpc>
-                <a:spcPct val="125000"/>
+                <a:spcPct val="120000"/>
               </a:lnSpc>
-              <a:spcAft>
-                <a:spcPts val="600"/>
-              </a:spcAft>
               <a:buNone/>
               <a:defRPr lang="en-US" sz="1000" spc="100" kern="0" dirty="0">
                 <a:solidFill>
@@ -1578,11 +1598,8 @@
           <a:p>
             <a:pPr algn="l" indent="0" marL="0">
               <a:lnSpc>
-                <a:spcPct val="125000"/>
+                <a:spcPct val="120000"/>
               </a:lnSpc>
-              <a:spcAft>
-                <a:spcPts val="600"/>
-              </a:spcAft>
               <a:buNone/>
             </a:pPr>
             <a:r>
@@ -1620,7 +1637,7 @@
           <a:ln/>
         </p:spPr>
         <p:txBody>
-          <a:bodyPr wrap="square" rtlCol="0"/>
+          <a:bodyPr lIns="0" tIns="0" rIns="0" bIns="0" wrap="square" rtlCol="0"/>
           <a:lstStyle>
             <a:lvl1pPr algn="l" indent="0" marL="0">
               <a:lnSpc>
@@ -1679,15 +1696,12 @@
           <a:ln/>
         </p:spPr>
         <p:txBody>
-          <a:bodyPr wrap="square" rtlCol="0"/>
+          <a:bodyPr lIns="0" tIns="0" rIns="0" bIns="0" wrap="square" rtlCol="0"/>
           <a:lstStyle>
             <a:lvl1pPr algn="l" indent="0" marL="0">
               <a:lnSpc>
-                <a:spcPct val="125000"/>
+                <a:spcPct val="120000"/>
               </a:lnSpc>
-              <a:spcAft>
-                <a:spcPts val="600"/>
-              </a:spcAft>
               <a:buNone/>
               <a:defRPr lang="en-US" sz="1400" dirty="0">
                 <a:solidFill>
@@ -1702,11 +1716,8 @@
           <a:p>
             <a:pPr algn="l" indent="0" marL="0">
               <a:lnSpc>
-                <a:spcPct val="125000"/>
+                <a:spcPct val="120000"/>
               </a:lnSpc>
-              <a:spcAft>
-                <a:spcPts val="600"/>
-              </a:spcAft>
               <a:buNone/>
             </a:pPr>
             <a:r>
@@ -1744,15 +1755,12 @@
           <a:ln/>
         </p:spPr>
         <p:txBody>
-          <a:bodyPr wrap="square" rtlCol="0"/>
+          <a:bodyPr lIns="0" tIns="0" rIns="0" bIns="0" wrap="square" rtlCol="0"/>
           <a:lstStyle>
             <a:lvl1pPr algn="l" indent="0" marL="0">
               <a:lnSpc>
-                <a:spcPct val="125000"/>
+                <a:spcPct val="120000"/>
               </a:lnSpc>
-              <a:spcAft>
-                <a:spcPts val="600"/>
-              </a:spcAft>
               <a:buNone/>
               <a:defRPr lang="en-US" sz="900" dirty="0">
                 <a:solidFill>
@@ -1767,11 +1775,8 @@
           <a:p>
             <a:pPr algn="l" indent="0" marL="0">
               <a:lnSpc>
-                <a:spcPct val="125000"/>
+                <a:spcPct val="120000"/>
               </a:lnSpc>
-              <a:spcAft>
-                <a:spcPts val="600"/>
-              </a:spcAft>
               <a:buNone/>
             </a:pPr>
             <a:r>
@@ -1821,12 +1826,36 @@
           <a:chExt cx="0" cy="0"/>
         </a:xfrm>
       </p:grpSpPr>
-      <p:sp>
-        <p:nvSpPr>
-          <p:cNvPr id="2" name="Text 0"/>
+      <p:pic>
+        <p:nvPicPr>
+          <p:cNvPr id="2" name="Image 0" descr="CASI">    </p:cNvPr>
+          <p:cNvPicPr>
+            <a:picLocks noChangeAspect="1"/>
+          </p:cNvPicPr>
+          <p:nvPr/>
+        </p:nvPicPr>
+        <p:blipFill>
+          <a:blip r:embed="rId1"/>
+          <a:stretch>
+            <a:fillRect/>
+          </a:stretch>
+        </p:blipFill>
+        <p:spPr>
+          <a:xfrm>
+            <a:off x="612648" y="6437376"/>
+            <a:ext cx="163982" cy="182880"/>
+          </a:xfrm>
+          <a:prstGeom prst="rect">
+            <a:avLst/>
+          </a:prstGeom>
+        </p:spPr>
+      </p:pic>
+      <p:sp>
+        <p:nvSpPr>
+          <p:cNvPr id="3" name="Text 0"/>
           <p:cNvSpPr/>
           <p:nvPr>
-            <p:ph idx="100" type="body" hasCustomPrompt="1"/>
+            <p:ph idx="101" type="body" hasCustomPrompt="1"/>
           </p:nvPr>
         </p:nvSpPr>
         <p:spPr>
@@ -1841,15 +1870,12 @@
           <a:ln/>
         </p:spPr>
         <p:txBody>
-          <a:bodyPr wrap="square" rtlCol="0"/>
+          <a:bodyPr lIns="0" tIns="0" rIns="0" bIns="0" wrap="square" rtlCol="0"/>
           <a:lstStyle>
             <a:lvl1pPr algn="l" indent="0" marL="0">
               <a:lnSpc>
-                <a:spcPct val="125000"/>
+                <a:spcPct val="120000"/>
               </a:lnSpc>
-              <a:spcAft>
-                <a:spcPts val="600"/>
-              </a:spcAft>
               <a:buNone/>
               <a:defRPr lang="en-US" sz="1000" dirty="0">
                 <a:solidFill>
@@ -1864,11 +1890,8 @@
           <a:p>
             <a:pPr algn="l" indent="0" marL="0">
               <a:lnSpc>
-                <a:spcPct val="125000"/>
+                <a:spcPct val="120000"/>
               </a:lnSpc>
-              <a:spcAft>
-                <a:spcPts val="600"/>
-              </a:spcAft>
               <a:buNone/>
             </a:pPr>
             <a:r>
@@ -1888,10 +1911,10 @@
       </p:sp>
       <p:sp>
         <p:nvSpPr>
-          <p:cNvPr id="3" name="Text 0"/>
+          <p:cNvPr id="4" name="Text 0"/>
           <p:cNvSpPr/>
           <p:nvPr>
-            <p:ph idx="101" type="title" hasCustomPrompt="1"/>
+            <p:ph idx="102" type="title" hasCustomPrompt="1"/>
           </p:nvPr>
         </p:nvSpPr>
         <p:spPr>
@@ -1906,7 +1929,7 @@
           <a:ln/>
         </p:spPr>
         <p:txBody>
-          <a:bodyPr wrap="square" rtlCol="0"/>
+          <a:bodyPr lIns="0" tIns="0" rIns="0" bIns="0" wrap="square" rtlCol="0"/>
           <a:lstStyle>
             <a:lvl1pPr algn="l" indent="0" marL="0">
               <a:lnSpc>
@@ -2025,12 +2048,36 @@
           <a:chExt cx="0" cy="0"/>
         </a:xfrm>
       </p:grpSpPr>
-      <p:sp>
-        <p:nvSpPr>
-          <p:cNvPr id="2" name="Text 0"/>
+      <p:pic>
+        <p:nvPicPr>
+          <p:cNvPr id="2" name="Image 0" descr="CASI">    </p:cNvPr>
+          <p:cNvPicPr>
+            <a:picLocks noChangeAspect="1"/>
+          </p:cNvPicPr>
+          <p:nvPr/>
+        </p:nvPicPr>
+        <p:blipFill>
+          <a:blip r:embed="rId1"/>
+          <a:stretch>
+            <a:fillRect/>
+          </a:stretch>
+        </p:blipFill>
+        <p:spPr>
+          <a:xfrm>
+            <a:off x="612648" y="6437376"/>
+            <a:ext cx="163982" cy="182880"/>
+          </a:xfrm>
+          <a:prstGeom prst="rect">
+            <a:avLst/>
+          </a:prstGeom>
+        </p:spPr>
+      </p:pic>
+      <p:sp>
+        <p:nvSpPr>
+          <p:cNvPr id="3" name="Text 0"/>
           <p:cNvSpPr/>
           <p:nvPr>
-            <p:ph idx="100" type="title" hasCustomPrompt="1"/>
+            <p:ph idx="101" type="title" hasCustomPrompt="1"/>
           </p:nvPr>
         </p:nvSpPr>
         <p:spPr>
@@ -2045,7 +2092,7 @@
           <a:ln/>
         </p:spPr>
         <p:txBody>
-          <a:bodyPr wrap="square" rtlCol="0"/>
+          <a:bodyPr lIns="0" tIns="0" rIns="0" bIns="0" wrap="square" rtlCol="0"/>
           <a:lstStyle>
             <a:lvl1pPr algn="l" indent="0" marL="0">
               <a:buNone/>
@@ -2080,10 +2127,10 @@
       </p:sp>
       <p:sp>
         <p:nvSpPr>
-          <p:cNvPr id="3" name="Text 0"/>
+          <p:cNvPr id="4" name="Text 0"/>
           <p:cNvSpPr/>
           <p:nvPr>
-            <p:ph idx="101" type="body" hasCustomPrompt="1"/>
+            <p:ph idx="102" type="body" hasCustomPrompt="1"/>
           </p:nvPr>
         </p:nvSpPr>
         <p:spPr>
@@ -2098,11 +2145,11 @@
           <a:ln/>
         </p:spPr>
         <p:txBody>
-          <a:bodyPr wrap="square" rtlCol="0"/>
+          <a:bodyPr lIns="0" tIns="0" rIns="0" bIns="0" wrap="square" rtlCol="0"/>
           <a:lstStyle>
             <a:lvl1pPr algn="l" indent="0" marL="0">
               <a:lnSpc>
-                <a:spcPct val="125000"/>
+                <a:spcPct val="135000"/>
               </a:lnSpc>
               <a:spcAft>
                 <a:spcPts val="600"/>
@@ -2112,16 +2159,16 @@
                 <a:solidFill>
                   <a:srgbClr val="0E4D49"/>
                 </a:solidFill>
-                <a:latin typeface="PP Mori" pitchFamily="34" charset="0"/>
-                <a:ea typeface="PP Mori" pitchFamily="34" charset="-122"/>
-                <a:cs typeface="PP Mori" pitchFamily="34" charset="-120"/>
+                <a:latin typeface="IBM Plex Serif" pitchFamily="34" charset="0"/>
+                <a:ea typeface="IBM Plex Serif" pitchFamily="34" charset="-122"/>
+                <a:cs typeface="IBM Plex Serif" pitchFamily="34" charset="-120"/>
               </a:defRPr>
             </a:lvl1pPr>
           </a:lstStyle>
           <a:p>
             <a:pPr algn="l" indent="0" marL="0">
               <a:lnSpc>
-                <a:spcPct val="125000"/>
+                <a:spcPct val="135000"/>
               </a:lnSpc>
               <a:spcAft>
                 <a:spcPts val="600"/>
@@ -2133,9 +2180,9 @@
                 <a:solidFill>
                   <a:srgbClr val="0E4D49"/>
                 </a:solidFill>
-                <a:latin typeface="PP Mori" pitchFamily="34" charset="0"/>
-                <a:ea typeface="PP Mori" pitchFamily="34" charset="-122"/>
-                <a:cs typeface="PP Mori" pitchFamily="34" charset="-120"/>
+                <a:latin typeface="IBM Plex Serif" pitchFamily="34" charset="0"/>
+                <a:ea typeface="IBM Plex Serif" pitchFamily="34" charset="-122"/>
+                <a:cs typeface="IBM Plex Serif" pitchFamily="34" charset="-120"/>
               </a:rPr>
               <a:t>Text hinzufügen</a:t>
             </a:r>
@@ -2223,12 +2270,36 @@
           <a:chExt cx="0" cy="0"/>
         </a:xfrm>
       </p:grpSpPr>
-      <p:sp>
-        <p:nvSpPr>
-          <p:cNvPr id="2" name="Text 0"/>
+      <p:pic>
+        <p:nvPicPr>
+          <p:cNvPr id="2" name="Image 0" descr="CASI">    </p:cNvPr>
+          <p:cNvPicPr>
+            <a:picLocks noChangeAspect="1"/>
+          </p:cNvPicPr>
+          <p:nvPr/>
+        </p:nvPicPr>
+        <p:blipFill>
+          <a:blip r:embed="rId1"/>
+          <a:stretch>
+            <a:fillRect/>
+          </a:stretch>
+        </p:blipFill>
+        <p:spPr>
+          <a:xfrm>
+            <a:off x="612648" y="6437376"/>
+            <a:ext cx="163982" cy="182880"/>
+          </a:xfrm>
+          <a:prstGeom prst="rect">
+            <a:avLst/>
+          </a:prstGeom>
+        </p:spPr>
+      </p:pic>
+      <p:sp>
+        <p:nvSpPr>
+          <p:cNvPr id="3" name="Text 0"/>
           <p:cNvSpPr/>
           <p:nvPr>
-            <p:ph idx="100" type="title" hasCustomPrompt="1"/>
+            <p:ph idx="101" type="title" hasCustomPrompt="1"/>
           </p:nvPr>
         </p:nvSpPr>
         <p:spPr>
@@ -2243,7 +2314,7 @@
           <a:ln/>
         </p:spPr>
         <p:txBody>
-          <a:bodyPr wrap="square" rtlCol="0"/>
+          <a:bodyPr lIns="0" tIns="0" rIns="0" bIns="0" wrap="square" rtlCol="0"/>
           <a:lstStyle>
             <a:lvl1pPr algn="l" indent="0" marL="0">
               <a:buNone/>
@@ -2356,12 +2427,36 @@
           <a:chExt cx="0" cy="0"/>
         </a:xfrm>
       </p:grpSpPr>
-      <p:sp>
-        <p:nvSpPr>
-          <p:cNvPr id="2" name="Text 0"/>
+      <p:pic>
+        <p:nvPicPr>
+          <p:cNvPr id="2" name="Image 0" descr="CASI">    </p:cNvPr>
+          <p:cNvPicPr>
+            <a:picLocks noChangeAspect="1"/>
+          </p:cNvPicPr>
+          <p:nvPr/>
+        </p:nvPicPr>
+        <p:blipFill>
+          <a:blip r:embed="rId1"/>
+          <a:stretch>
+            <a:fillRect/>
+          </a:stretch>
+        </p:blipFill>
+        <p:spPr>
+          <a:xfrm>
+            <a:off x="612648" y="6437376"/>
+            <a:ext cx="163982" cy="182880"/>
+          </a:xfrm>
+          <a:prstGeom prst="rect">
+            <a:avLst/>
+          </a:prstGeom>
+        </p:spPr>
+      </p:pic>
+      <p:sp>
+        <p:nvSpPr>
+          <p:cNvPr id="3" name="Text 0"/>
           <p:cNvSpPr/>
           <p:nvPr>
-            <p:ph idx="100" type="title" hasCustomPrompt="1"/>
+            <p:ph idx="101" type="title" hasCustomPrompt="1"/>
           </p:nvPr>
         </p:nvSpPr>
         <p:spPr>
@@ -2376,7 +2471,7 @@
           <a:ln/>
         </p:spPr>
         <p:txBody>
-          <a:bodyPr wrap="square" rtlCol="0"/>
+          <a:bodyPr lIns="0" tIns="0" rIns="0" bIns="0" wrap="square" rtlCol="0"/>
           <a:lstStyle>
             <a:lvl1pPr algn="l" indent="0" marL="0">
               <a:buNone/>
@@ -2411,10 +2506,10 @@
       </p:sp>
       <p:sp>
         <p:nvSpPr>
-          <p:cNvPr id="3" name="Text 0"/>
+          <p:cNvPr id="4" name="Text 0"/>
           <p:cNvSpPr/>
           <p:nvPr>
-            <p:ph idx="101" type="body" hasCustomPrompt="1"/>
+            <p:ph idx="102" type="body" hasCustomPrompt="1"/>
           </p:nvPr>
         </p:nvSpPr>
         <p:spPr>
@@ -2429,11 +2524,11 @@
           <a:ln/>
         </p:spPr>
         <p:txBody>
-          <a:bodyPr wrap="square" rtlCol="0"/>
+          <a:bodyPr lIns="0" tIns="0" rIns="0" bIns="0" wrap="square" rtlCol="0"/>
           <a:lstStyle>
             <a:lvl1pPr algn="l" indent="0" marL="0">
               <a:lnSpc>
-                <a:spcPct val="125000"/>
+                <a:spcPct val="135000"/>
               </a:lnSpc>
               <a:spcAft>
                 <a:spcPts val="600"/>
@@ -2443,16 +2538,16 @@
                 <a:solidFill>
                   <a:srgbClr val="0E4D49"/>
                 </a:solidFill>
-                <a:latin typeface="PP Mori" pitchFamily="34" charset="0"/>
-                <a:ea typeface="PP Mori" pitchFamily="34" charset="-122"/>
-                <a:cs typeface="PP Mori" pitchFamily="34" charset="-120"/>
+                <a:latin typeface="IBM Plex Serif" pitchFamily="34" charset="0"/>
+                <a:ea typeface="IBM Plex Serif" pitchFamily="34" charset="-122"/>
+                <a:cs typeface="IBM Plex Serif" pitchFamily="34" charset="-120"/>
               </a:defRPr>
             </a:lvl1pPr>
           </a:lstStyle>
           <a:p>
             <a:pPr algn="l" indent="0" marL="0">
               <a:lnSpc>
-                <a:spcPct val="125000"/>
+                <a:spcPct val="135000"/>
               </a:lnSpc>
               <a:spcAft>
                 <a:spcPts val="600"/>
@@ -2464,9 +2559,9 @@
                 <a:solidFill>
                   <a:srgbClr val="0E4D49"/>
                 </a:solidFill>
-                <a:latin typeface="PP Mori" pitchFamily="34" charset="0"/>
-                <a:ea typeface="PP Mori" pitchFamily="34" charset="-122"/>
-                <a:cs typeface="PP Mori" pitchFamily="34" charset="-120"/>
+                <a:latin typeface="IBM Plex Serif" pitchFamily="34" charset="0"/>
+                <a:ea typeface="IBM Plex Serif" pitchFamily="34" charset="-122"/>
+                <a:cs typeface="IBM Plex Serif" pitchFamily="34" charset="-120"/>
               </a:rPr>
               <a:t>Text hinzufügen</a:t>
             </a:r>
@@ -2476,10 +2571,10 @@
       </p:sp>
       <p:sp>
         <p:nvSpPr>
-          <p:cNvPr id="4" name="Text 0"/>
+          <p:cNvPr id="5" name="Text 0"/>
           <p:cNvSpPr/>
           <p:nvPr>
-            <p:ph idx="102" type="body" hasCustomPrompt="1"/>
+            <p:ph idx="103" type="body" hasCustomPrompt="1"/>
           </p:nvPr>
         </p:nvSpPr>
         <p:spPr>
@@ -2494,11 +2589,11 @@
           <a:ln/>
         </p:spPr>
         <p:txBody>
-          <a:bodyPr wrap="square" rtlCol="0"/>
+          <a:bodyPr lIns="0" tIns="0" rIns="0" bIns="0" wrap="square" rtlCol="0"/>
           <a:lstStyle>
             <a:lvl1pPr algn="l" indent="0" marL="0">
               <a:lnSpc>
-                <a:spcPct val="125000"/>
+                <a:spcPct val="135000"/>
               </a:lnSpc>
               <a:spcAft>
                 <a:spcPts val="600"/>
@@ -2508,16 +2603,16 @@
                 <a:solidFill>
                   <a:srgbClr val="0E4D49"/>
                 </a:solidFill>
-                <a:latin typeface="PP Mori" pitchFamily="34" charset="0"/>
-                <a:ea typeface="PP Mori" pitchFamily="34" charset="-122"/>
-                <a:cs typeface="PP Mori" pitchFamily="34" charset="-120"/>
+                <a:latin typeface="IBM Plex Serif" pitchFamily="34" charset="0"/>
+                <a:ea typeface="IBM Plex Serif" pitchFamily="34" charset="-122"/>
+                <a:cs typeface="IBM Plex Serif" pitchFamily="34" charset="-120"/>
               </a:defRPr>
             </a:lvl1pPr>
           </a:lstStyle>
           <a:p>
             <a:pPr algn="l" indent="0" marL="0">
               <a:lnSpc>
-                <a:spcPct val="125000"/>
+                <a:spcPct val="135000"/>
               </a:lnSpc>
               <a:spcAft>
                 <a:spcPts val="600"/>
@@ -2529,9 +2624,9 @@
                 <a:solidFill>
                   <a:srgbClr val="0E4D49"/>
                 </a:solidFill>
-                <a:latin typeface="PP Mori" pitchFamily="34" charset="0"/>
-                <a:ea typeface="PP Mori" pitchFamily="34" charset="-122"/>
-                <a:cs typeface="PP Mori" pitchFamily="34" charset="-120"/>
+                <a:latin typeface="IBM Plex Serif" pitchFamily="34" charset="0"/>
+                <a:ea typeface="IBM Plex Serif" pitchFamily="34" charset="-122"/>
+                <a:cs typeface="IBM Plex Serif" pitchFamily="34" charset="-120"/>
               </a:rPr>
               <a:t>Text hinzufügen</a:t>
             </a:r>
@@ -2597,7 +2692,7 @@
 
 <file path=ppt/slideLayouts/slideLayout7.xml><?xml version="1.0" encoding="utf-8"?>
 <p:sldLayout xmlns:a="http://schemas.openxmlformats.org/drawingml/2006/main" xmlns:r="http://schemas.openxmlformats.org/officeDocument/2006/relationships" xmlns:p="http://schemas.openxmlformats.org/presentationml/2006/main" preserve="1">
-  <p:cSld name="Box">
+  <p:cSld name="Text mit Box">
     <p:bg>
       <p:bgPr>
         <a:solidFill>
@@ -2619,12 +2714,36 @@
           <a:chExt cx="0" cy="0"/>
         </a:xfrm>
       </p:grpSpPr>
-      <p:sp>
-        <p:nvSpPr>
-          <p:cNvPr id="2" name="Text 0"/>
+      <p:pic>
+        <p:nvPicPr>
+          <p:cNvPr id="2" name="Image 0" descr="CASI">    </p:cNvPr>
+          <p:cNvPicPr>
+            <a:picLocks noChangeAspect="1"/>
+          </p:cNvPicPr>
+          <p:nvPr/>
+        </p:nvPicPr>
+        <p:blipFill>
+          <a:blip r:embed="rId1"/>
+          <a:stretch>
+            <a:fillRect/>
+          </a:stretch>
+        </p:blipFill>
+        <p:spPr>
+          <a:xfrm>
+            <a:off x="612648" y="6437376"/>
+            <a:ext cx="163982" cy="182880"/>
+          </a:xfrm>
+          <a:prstGeom prst="rect">
+            <a:avLst/>
+          </a:prstGeom>
+        </p:spPr>
+      </p:pic>
+      <p:sp>
+        <p:nvSpPr>
+          <p:cNvPr id="3" name="Text 0"/>
           <p:cNvSpPr/>
           <p:nvPr>
-            <p:ph idx="100" type="title" hasCustomPrompt="1"/>
+            <p:ph idx="101" type="title" hasCustomPrompt="1"/>
           </p:nvPr>
         </p:nvSpPr>
         <p:spPr>
@@ -2639,7 +2758,7 @@
           <a:ln/>
         </p:spPr>
         <p:txBody>
-          <a:bodyPr wrap="square" rtlCol="0"/>
+          <a:bodyPr lIns="0" tIns="0" rIns="0" bIns="0" wrap="square" rtlCol="0"/>
           <a:lstStyle>
             <a:lvl1pPr algn="l" indent="0" marL="0">
               <a:buNone/>
@@ -2674,48 +2793,16 @@
       </p:sp>
       <p:sp>
         <p:nvSpPr>
-          <p:cNvPr id="3" name="Text 0"/>
+          <p:cNvPr id="4" name="Text 0"/>
           <p:cNvSpPr/>
-          <p:nvPr/>
+          <p:nvPr>
+            <p:ph idx="102" type="body" hasCustomPrompt="1"/>
+          </p:nvPr>
         </p:nvSpPr>
         <p:spPr>
           <a:xfrm>
             <a:off x="612648" y="960120"/>
-            <a:ext cx="10966399" cy="5440680"/>
-          </a:xfrm>
-          <a:prstGeom prst="roundRect">
-            <a:avLst>
-              <a:gd name="adj" fmla="val 1681"/>
-            </a:avLst>
-          </a:prstGeom>
-          <a:solidFill>
-            <a:srgbClr val="EEF2F1"/>
-          </a:solidFill>
-          <a:ln/>
-        </p:spPr>
-        <p:txBody>
-          <a:bodyPr wrap="square" rtlCol="0" anchor="ctr"/>
-          <a:lstStyle/>
-          <a:p>
-            <a:pPr indent="0" marL="0">
-              <a:buNone/>
-            </a:pPr>
-            <a:endParaRPr lang="en-US" dirty="0"/>
-          </a:p>
-        </p:txBody>
-      </p:sp>
-      <p:sp>
-        <p:nvSpPr>
-          <p:cNvPr id="4" name="Text 1"/>
-          <p:cNvSpPr/>
-          <p:nvPr>
-            <p:ph idx="102" type="body" hasCustomPrompt="1"/>
-          </p:nvPr>
-        </p:nvSpPr>
-        <p:spPr>
-          <a:xfrm>
-            <a:off x="886968" y="1234440"/>
-            <a:ext cx="10417759" cy="4892040"/>
+            <a:ext cx="6760159" cy="5440680"/>
           </a:xfrm>
           <a:prstGeom prst="rect">
             <a:avLst/>
@@ -2724,11 +2811,11 @@
           <a:ln/>
         </p:spPr>
         <p:txBody>
-          <a:bodyPr wrap="square" rtlCol="0"/>
+          <a:bodyPr lIns="0" tIns="0" rIns="0" bIns="0" wrap="square" rtlCol="0"/>
           <a:lstStyle>
             <a:lvl1pPr algn="l" indent="0" marL="0">
               <a:lnSpc>
-                <a:spcPct val="125000"/>
+                <a:spcPct val="135000"/>
               </a:lnSpc>
               <a:spcAft>
                 <a:spcPts val="600"/>
@@ -2738,16 +2825,16 @@
                 <a:solidFill>
                   <a:srgbClr val="0E4D49"/>
                 </a:solidFill>
-                <a:latin typeface="PP Mori" pitchFamily="34" charset="0"/>
-                <a:ea typeface="PP Mori" pitchFamily="34" charset="-122"/>
-                <a:cs typeface="PP Mori" pitchFamily="34" charset="-120"/>
+                <a:latin typeface="IBM Plex Serif" pitchFamily="34" charset="0"/>
+                <a:ea typeface="IBM Plex Serif" pitchFamily="34" charset="-122"/>
+                <a:cs typeface="IBM Plex Serif" pitchFamily="34" charset="-120"/>
               </a:defRPr>
             </a:lvl1pPr>
           </a:lstStyle>
           <a:p>
             <a:pPr algn="l" indent="0" marL="0">
               <a:lnSpc>
-                <a:spcPct val="125000"/>
+                <a:spcPct val="135000"/>
               </a:lnSpc>
               <a:spcAft>
                 <a:spcPts val="600"/>
@@ -2759,11 +2846,84 @@
                 <a:solidFill>
                   <a:srgbClr val="0E4D49"/>
                 </a:solidFill>
-                <a:latin typeface="PP Mori" pitchFamily="34" charset="0"/>
-                <a:ea typeface="PP Mori" pitchFamily="34" charset="-122"/>
-                <a:cs typeface="PP Mori" pitchFamily="34" charset="-120"/>
+                <a:latin typeface="IBM Plex Serif" pitchFamily="34" charset="0"/>
+                <a:ea typeface="IBM Plex Serif" pitchFamily="34" charset="-122"/>
+                <a:cs typeface="IBM Plex Serif" pitchFamily="34" charset="-120"/>
               </a:rPr>
               <a:t>Text hinzufügen</a:t>
+            </a:r>
+            <a:endParaRPr lang="en-US" sz="1200" dirty="0"/>
+          </a:p>
+        </p:txBody>
+      </p:sp>
+      <p:sp>
+        <p:nvSpPr>
+          <p:cNvPr id="5" name="Text 0"/>
+          <p:cNvSpPr/>
+          <p:nvPr>
+            <p:ph idx="103" type="body" hasCustomPrompt="1"/>
+          </p:nvPr>
+        </p:nvSpPr>
+        <p:spPr>
+          <a:xfrm>
+            <a:off x="7738567" y="960120"/>
+            <a:ext cx="3840480" cy="1097280"/>
+          </a:xfrm>
+          <a:prstGeom prst="roundRect">
+            <a:avLst>
+              <a:gd name="adj" fmla="val 4000"/>
+            </a:avLst>
+          </a:prstGeom>
+          <a:solidFill>
+            <a:srgbClr val="EEF2F1"/>
+          </a:solidFill>
+          <a:ln>
+            <a:noFill/>
+          </a:ln>
+        </p:spPr>
+        <p:txBody>
+          <a:bodyPr wrap="square" rtlCol="0" lIns="274320" tIns="274320" rIns="274320" bIns="274320">
+            <a:spAutoFit/>
+          </a:bodyPr>
+          <a:lstStyle>
+            <a:lvl1pPr algn="l" indent="0" marL="0">
+              <a:lnSpc>
+                <a:spcPct val="135000"/>
+              </a:lnSpc>
+              <a:spcAft>
+                <a:spcPts val="600"/>
+              </a:spcAft>
+              <a:buNone/>
+              <a:defRPr lang="en-US" sz="1200" dirty="0">
+                <a:solidFill>
+                  <a:srgbClr val="0E4D49"/>
+                </a:solidFill>
+                <a:latin typeface="IBM Plex Serif" pitchFamily="34" charset="0"/>
+                <a:ea typeface="IBM Plex Serif" pitchFamily="34" charset="-122"/>
+                <a:cs typeface="IBM Plex Serif" pitchFamily="34" charset="-120"/>
+              </a:defRPr>
+            </a:lvl1pPr>
+          </a:lstStyle>
+          <a:p>
+            <a:pPr algn="l" indent="0" marL="0">
+              <a:lnSpc>
+                <a:spcPct val="135000"/>
+              </a:lnSpc>
+              <a:spcAft>
+                <a:spcPts val="600"/>
+              </a:spcAft>
+              <a:buNone/>
+            </a:pPr>
+            <a:r>
+              <a:rPr lang="en-US" sz="1200" dirty="0">
+                <a:solidFill>
+                  <a:srgbClr val="0E4D49"/>
+                </a:solidFill>
+                <a:latin typeface="IBM Plex Serif" pitchFamily="34" charset="0"/>
+                <a:ea typeface="IBM Plex Serif" pitchFamily="34" charset="-122"/>
+                <a:cs typeface="IBM Plex Serif" pitchFamily="34" charset="-120"/>
+              </a:rPr>
+              <a:t>Text in der Box</a:t>
             </a:r>
             <a:endParaRPr lang="en-US" sz="1200" dirty="0"/>
           </a:p>
@@ -2849,12 +3009,36 @@
           <a:chExt cx="0" cy="0"/>
         </a:xfrm>
       </p:grpSpPr>
-      <p:sp>
-        <p:nvSpPr>
-          <p:cNvPr id="2" name="Text 0"/>
+      <p:pic>
+        <p:nvPicPr>
+          <p:cNvPr id="2" name="Image 0" descr="CASI">    </p:cNvPr>
+          <p:cNvPicPr>
+            <a:picLocks noChangeAspect="1"/>
+          </p:cNvPicPr>
+          <p:nvPr/>
+        </p:nvPicPr>
+        <p:blipFill>
+          <a:blip r:embed="rId1"/>
+          <a:stretch>
+            <a:fillRect/>
+          </a:stretch>
+        </p:blipFill>
+        <p:spPr>
+          <a:xfrm>
+            <a:off x="612648" y="6437376"/>
+            <a:ext cx="163982" cy="182880"/>
+          </a:xfrm>
+          <a:prstGeom prst="rect">
+            <a:avLst/>
+          </a:prstGeom>
+        </p:spPr>
+      </p:pic>
+      <p:sp>
+        <p:nvSpPr>
+          <p:cNvPr id="3" name="Text 0"/>
           <p:cNvSpPr/>
           <p:nvPr>
-            <p:ph idx="100" type="title" hasCustomPrompt="1"/>
+            <p:ph idx="101" type="title" hasCustomPrompt="1"/>
           </p:nvPr>
         </p:nvSpPr>
         <p:spPr>
@@ -2869,7 +3053,7 @@
           <a:ln/>
         </p:spPr>
         <p:txBody>
-          <a:bodyPr wrap="square" rtlCol="0"/>
+          <a:bodyPr lIns="0" tIns="0" rIns="0" bIns="0" wrap="square" rtlCol="0"/>
           <a:lstStyle>
             <a:lvl1pPr algn="l" indent="0" marL="0">
               <a:buNone/>
@@ -2904,93 +3088,37 @@
       </p:sp>
       <p:sp>
         <p:nvSpPr>
-          <p:cNvPr id="3" name="Text 0"/>
+          <p:cNvPr id="4" name="Text 0"/>
           <p:cNvSpPr/>
-          <p:nvPr/>
+          <p:nvPr>
+            <p:ph idx="102" type="body" hasCustomPrompt="1"/>
+          </p:nvPr>
         </p:nvSpPr>
         <p:spPr>
           <a:xfrm>
             <a:off x="612648" y="960120"/>
-            <a:ext cx="5300320" cy="5440680"/>
+            <a:ext cx="5300320" cy="1097280"/>
           </a:xfrm>
           <a:prstGeom prst="roundRect">
             <a:avLst>
-              <a:gd name="adj" fmla="val 1725"/>
+              <a:gd name="adj" fmla="val 4000"/>
             </a:avLst>
           </a:prstGeom>
           <a:solidFill>
             <a:srgbClr val="EEF2F1"/>
           </a:solidFill>
-          <a:ln/>
-        </p:spPr>
-        <p:txBody>
-          <a:bodyPr wrap="square" rtlCol="0" anchor="ctr"/>
-          <a:lstStyle/>
-          <a:p>
-            <a:pPr indent="0" marL="0">
-              <a:buNone/>
-            </a:pPr>
-            <a:endParaRPr lang="en-US" dirty="0"/>
-          </a:p>
-        </p:txBody>
-      </p:sp>
-      <p:sp>
-        <p:nvSpPr>
-          <p:cNvPr id="4" name="Text 1"/>
-          <p:cNvSpPr/>
-          <p:nvPr/>
-        </p:nvSpPr>
-        <p:spPr>
-          <a:xfrm>
-            <a:off x="6278728" y="960120"/>
-            <a:ext cx="5300320" cy="5440680"/>
-          </a:xfrm>
-          <a:prstGeom prst="roundRect">
-            <a:avLst>
-              <a:gd name="adj" fmla="val 1725"/>
-            </a:avLst>
-          </a:prstGeom>
-          <a:solidFill>
-            <a:srgbClr val="EEF2F1"/>
-          </a:solidFill>
-          <a:ln/>
-        </p:spPr>
-        <p:txBody>
-          <a:bodyPr wrap="square" rtlCol="0" anchor="ctr"/>
-          <a:lstStyle/>
-          <a:p>
-            <a:pPr indent="0" marL="0">
-              <a:buNone/>
-            </a:pPr>
-            <a:endParaRPr lang="en-US" dirty="0"/>
-          </a:p>
-        </p:txBody>
-      </p:sp>
-      <p:sp>
-        <p:nvSpPr>
-          <p:cNvPr id="5" name="Text 2"/>
-          <p:cNvSpPr/>
-          <p:nvPr>
-            <p:ph idx="103" type="body" hasCustomPrompt="1"/>
-          </p:nvPr>
-        </p:nvSpPr>
-        <p:spPr>
-          <a:xfrm>
-            <a:off x="886968" y="1234440"/>
-            <a:ext cx="4751680" cy="4892040"/>
-          </a:xfrm>
-          <a:prstGeom prst="rect">
-            <a:avLst/>
-          </a:prstGeom>
-          <a:noFill/>
-          <a:ln/>
-        </p:spPr>
-        <p:txBody>
-          <a:bodyPr wrap="square" rtlCol="0"/>
+          <a:ln>
+            <a:noFill/>
+          </a:ln>
+        </p:spPr>
+        <p:txBody>
+          <a:bodyPr wrap="square" rtlCol="0" lIns="274320" tIns="274320" rIns="274320" bIns="274320">
+            <a:spAutoFit/>
+          </a:bodyPr>
           <a:lstStyle>
             <a:lvl1pPr algn="l" indent="0" marL="0">
               <a:lnSpc>
-                <a:spcPct val="125000"/>
+                <a:spcPct val="135000"/>
               </a:lnSpc>
               <a:spcAft>
                 <a:spcPts val="600"/>
@@ -3000,16 +3128,16 @@
                 <a:solidFill>
                   <a:srgbClr val="0E4D49"/>
                 </a:solidFill>
-                <a:latin typeface="PP Mori" pitchFamily="34" charset="0"/>
-                <a:ea typeface="PP Mori" pitchFamily="34" charset="-122"/>
-                <a:cs typeface="PP Mori" pitchFamily="34" charset="-120"/>
+                <a:latin typeface="IBM Plex Serif" pitchFamily="34" charset="0"/>
+                <a:ea typeface="IBM Plex Serif" pitchFamily="34" charset="-122"/>
+                <a:cs typeface="IBM Plex Serif" pitchFamily="34" charset="-120"/>
               </a:defRPr>
             </a:lvl1pPr>
           </a:lstStyle>
           <a:p>
             <a:pPr algn="l" indent="0" marL="0">
               <a:lnSpc>
-                <a:spcPct val="125000"/>
+                <a:spcPct val="135000"/>
               </a:lnSpc>
               <a:spcAft>
                 <a:spcPts val="600"/>
@@ -3021,11 +3149,11 @@
                 <a:solidFill>
                   <a:srgbClr val="0E4D49"/>
                 </a:solidFill>
-                <a:latin typeface="PP Mori" pitchFamily="34" charset="0"/>
-                <a:ea typeface="PP Mori" pitchFamily="34" charset="-122"/>
-                <a:cs typeface="PP Mori" pitchFamily="34" charset="-120"/>
+                <a:latin typeface="IBM Plex Serif" pitchFamily="34" charset="0"/>
+                <a:ea typeface="IBM Plex Serif" pitchFamily="34" charset="-122"/>
+                <a:cs typeface="IBM Plex Serif" pitchFamily="34" charset="-120"/>
               </a:rPr>
-              <a:t>Text hinzufügen</a:t>
+              <a:t>Text in der Box</a:t>
             </a:r>
             <a:endParaRPr lang="en-US" sz="1200" dirty="0"/>
           </a:p>
@@ -3033,29 +3161,37 @@
       </p:sp>
       <p:sp>
         <p:nvSpPr>
-          <p:cNvPr id="6" name="Text 2"/>
+          <p:cNvPr id="5" name="Text 0"/>
           <p:cNvSpPr/>
           <p:nvPr>
-            <p:ph idx="104" type="body" hasCustomPrompt="1"/>
-          </p:nvPr>
-        </p:nvSpPr>
-        <p:spPr>
-          <a:xfrm>
-            <a:off x="6553048" y="1234440"/>
-            <a:ext cx="4751680" cy="4892040"/>
-          </a:xfrm>
-          <a:prstGeom prst="rect">
-            <a:avLst/>
-          </a:prstGeom>
-          <a:noFill/>
-          <a:ln/>
-        </p:spPr>
-        <p:txBody>
-          <a:bodyPr wrap="square" rtlCol="0"/>
+            <p:ph idx="103" type="body" hasCustomPrompt="1"/>
+          </p:nvPr>
+        </p:nvSpPr>
+        <p:spPr>
+          <a:xfrm>
+            <a:off x="6278728" y="960120"/>
+            <a:ext cx="5300320" cy="1097280"/>
+          </a:xfrm>
+          <a:prstGeom prst="roundRect">
+            <a:avLst>
+              <a:gd name="adj" fmla="val 4000"/>
+            </a:avLst>
+          </a:prstGeom>
+          <a:solidFill>
+            <a:srgbClr val="EEF2F1"/>
+          </a:solidFill>
+          <a:ln>
+            <a:noFill/>
+          </a:ln>
+        </p:spPr>
+        <p:txBody>
+          <a:bodyPr wrap="square" rtlCol="0" lIns="274320" tIns="274320" rIns="274320" bIns="274320">
+            <a:spAutoFit/>
+          </a:bodyPr>
           <a:lstStyle>
             <a:lvl1pPr algn="l" indent="0" marL="0">
               <a:lnSpc>
-                <a:spcPct val="125000"/>
+                <a:spcPct val="135000"/>
               </a:lnSpc>
               <a:spcAft>
                 <a:spcPts val="600"/>
@@ -3065,16 +3201,16 @@
                 <a:solidFill>
                   <a:srgbClr val="0E4D49"/>
                 </a:solidFill>
-                <a:latin typeface="PP Mori" pitchFamily="34" charset="0"/>
-                <a:ea typeface="PP Mori" pitchFamily="34" charset="-122"/>
-                <a:cs typeface="PP Mori" pitchFamily="34" charset="-120"/>
+                <a:latin typeface="IBM Plex Serif" pitchFamily="34" charset="0"/>
+                <a:ea typeface="IBM Plex Serif" pitchFamily="34" charset="-122"/>
+                <a:cs typeface="IBM Plex Serif" pitchFamily="34" charset="-120"/>
               </a:defRPr>
             </a:lvl1pPr>
           </a:lstStyle>
           <a:p>
             <a:pPr algn="l" indent="0" marL="0">
               <a:lnSpc>
-                <a:spcPct val="125000"/>
+                <a:spcPct val="135000"/>
               </a:lnSpc>
               <a:spcAft>
                 <a:spcPts val="600"/>
@@ -3086,11 +3222,11 @@
                 <a:solidFill>
                   <a:srgbClr val="0E4D49"/>
                 </a:solidFill>
-                <a:latin typeface="PP Mori" pitchFamily="34" charset="0"/>
-                <a:ea typeface="PP Mori" pitchFamily="34" charset="-122"/>
-                <a:cs typeface="PP Mori" pitchFamily="34" charset="-120"/>
+                <a:latin typeface="IBM Plex Serif" pitchFamily="34" charset="0"/>
+                <a:ea typeface="IBM Plex Serif" pitchFamily="34" charset="-122"/>
+                <a:cs typeface="IBM Plex Serif" pitchFamily="34" charset="-120"/>
               </a:rPr>
-              <a:t>Text hinzufügen</a:t>
+              <a:t>Text in der Box</a:t>
             </a:r>
             <a:endParaRPr lang="en-US" sz="1200" dirty="0"/>
           </a:p>
@@ -3176,12 +3312,36 @@
           <a:chExt cx="0" cy="0"/>
         </a:xfrm>
       </p:grpSpPr>
-      <p:sp>
-        <p:nvSpPr>
-          <p:cNvPr id="2" name="Text 0"/>
+      <p:pic>
+        <p:nvPicPr>
+          <p:cNvPr id="2" name="Image 0" descr="CASI">    </p:cNvPr>
+          <p:cNvPicPr>
+            <a:picLocks noChangeAspect="1"/>
+          </p:cNvPicPr>
+          <p:nvPr/>
+        </p:nvPicPr>
+        <p:blipFill>
+          <a:blip r:embed="rId1"/>
+          <a:stretch>
+            <a:fillRect/>
+          </a:stretch>
+        </p:blipFill>
+        <p:spPr>
+          <a:xfrm>
+            <a:off x="612648" y="6437376"/>
+            <a:ext cx="163982" cy="182880"/>
+          </a:xfrm>
+          <a:prstGeom prst="rect">
+            <a:avLst/>
+          </a:prstGeom>
+        </p:spPr>
+      </p:pic>
+      <p:sp>
+        <p:nvSpPr>
+          <p:cNvPr id="3" name="Text 0"/>
           <p:cNvSpPr/>
           <p:nvPr>
-            <p:ph idx="100" type="title" hasCustomPrompt="1"/>
+            <p:ph idx="101" type="title" hasCustomPrompt="1"/>
           </p:nvPr>
         </p:nvSpPr>
         <p:spPr>
@@ -3196,7 +3356,7 @@
           <a:ln/>
         </p:spPr>
         <p:txBody>
-          <a:bodyPr wrap="square" rtlCol="0"/>
+          <a:bodyPr lIns="0" tIns="0" rIns="0" bIns="0" wrap="square" rtlCol="0"/>
           <a:lstStyle>
             <a:lvl1pPr algn="l" indent="0" marL="0">
               <a:buNone/>
@@ -3231,10 +3391,10 @@
       </p:sp>
       <p:sp>
         <p:nvSpPr>
-          <p:cNvPr id="3" name="Text 0"/>
+          <p:cNvPr id="4" name="Text 0"/>
           <p:cNvSpPr/>
           <p:nvPr>
-            <p:ph idx="101" hasCustomPrompt="1"/>
+            <p:ph idx="102" hasCustomPrompt="1"/>
           </p:nvPr>
         </p:nvSpPr>
         <p:spPr>
@@ -3249,7 +3409,7 @@
           <a:ln/>
         </p:spPr>
         <p:txBody>
-          <a:bodyPr wrap="square" rtlCol="0"/>
+          <a:bodyPr lIns="0" tIns="0" rIns="0" bIns="0" wrap="square" rtlCol="0"/>
           <a:lstStyle>
             <a:lvl1pPr indent="0" marL="0">
               <a:buNone/>
@@ -3278,10 +3438,10 @@
       </p:sp>
       <p:sp>
         <p:nvSpPr>
-          <p:cNvPr id="4" name="Text 0"/>
+          <p:cNvPr id="5" name="Text 0"/>
           <p:cNvSpPr/>
           <p:nvPr>
-            <p:ph idx="102" type="body" hasCustomPrompt="1"/>
+            <p:ph idx="103" type="body" hasCustomPrompt="1"/>
           </p:nvPr>
         </p:nvSpPr>
         <p:spPr>
@@ -3296,15 +3456,12 @@
           <a:ln/>
         </p:spPr>
         <p:txBody>
-          <a:bodyPr wrap="square" rtlCol="0"/>
+          <a:bodyPr lIns="0" tIns="0" rIns="0" bIns="0" wrap="square" rtlCol="0"/>
           <a:lstStyle>
             <a:lvl1pPr algn="l" indent="0" marL="0">
               <a:lnSpc>
                 <a:spcPct val="120000"/>
               </a:lnSpc>
-              <a:spcAft>
-                <a:spcPts val="600"/>
-              </a:spcAft>
               <a:buNone/>
               <a:defRPr lang="en-US" sz="750" dirty="0">
                 <a:solidFill>
@@ -3321,9 +3478,6 @@
               <a:lnSpc>
                 <a:spcPct val="120000"/>
               </a:lnSpc>
-              <a:spcAft>
-                <a:spcPts val="600"/>
-              </a:spcAft>
               <a:buNone/>
             </a:pPr>
             <a:r>
@@ -3774,11 +3928,8 @@
           <a:p>
             <a:pPr algn="l" indent="0" marL="0">
               <a:lnSpc>
-                <a:spcPct val="125000"/>
+                <a:spcPct val="120000"/>
               </a:lnSpc>
-              <a:spcAft>
-                <a:spcPts val="600"/>
-              </a:spcAft>
               <a:buNone/>
             </a:pPr>
             <a:r>
@@ -3865,11 +4016,8 @@
           <a:p>
             <a:pPr algn="l" indent="0" marL="0">
               <a:lnSpc>
-                <a:spcPct val="125000"/>
+                <a:spcPct val="120000"/>
               </a:lnSpc>
-              <a:spcAft>
-                <a:spcPts val="600"/>
-              </a:spcAft>
               <a:buNone/>
             </a:pPr>
             <a:r>
@@ -3912,11 +4060,8 @@
           <a:p>
             <a:pPr algn="l" indent="0" marL="0">
               <a:lnSpc>
-                <a:spcPct val="125000"/>
+                <a:spcPct val="120000"/>
               </a:lnSpc>
-              <a:spcAft>
-                <a:spcPts val="600"/>
-              </a:spcAft>
               <a:buNone/>
             </a:pPr>
             <a:r>
@@ -3964,7 +4109,7 @@
           <p:cNvPr id="2" name="Text 0"/>
           <p:cNvSpPr/>
           <p:nvPr>
-            <p:ph idx="100" type="body" hasCustomPrompt="1"/>
+            <p:ph idx="101" type="body" hasCustomPrompt="1"/>
           </p:nvPr>
         </p:nvSpPr>
         <p:spPr>
@@ -3984,11 +4129,8 @@
           <a:p>
             <a:pPr algn="l" indent="0" marL="0">
               <a:lnSpc>
-                <a:spcPct val="125000"/>
+                <a:spcPct val="120000"/>
               </a:lnSpc>
-              <a:spcAft>
-                <a:spcPts val="600"/>
-              </a:spcAft>
               <a:buNone/>
             </a:pPr>
             <a:r>
@@ -4011,7 +4153,7 @@
           <p:cNvPr id="3" name="Text 0"/>
           <p:cNvSpPr/>
           <p:nvPr>
-            <p:ph idx="101" type="title" hasCustomPrompt="1"/>
+            <p:ph idx="102" type="title" hasCustomPrompt="1"/>
           </p:nvPr>
         </p:nvSpPr>
         <p:spPr>
@@ -4128,7 +4270,7 @@
           <p:cNvPr id="2" name="Text 0"/>
           <p:cNvSpPr/>
           <p:nvPr>
-            <p:ph idx="100" type="title" hasCustomPrompt="1"/>
+            <p:ph idx="101" type="title" hasCustomPrompt="1"/>
           </p:nvPr>
         </p:nvSpPr>
         <p:spPr>
@@ -4169,7 +4311,7 @@
           <p:cNvPr id="3" name="Text 0"/>
           <p:cNvSpPr/>
           <p:nvPr>
-            <p:ph idx="101" type="body" hasCustomPrompt="1"/>
+            <p:ph idx="102" type="body" hasCustomPrompt="1"/>
           </p:nvPr>
         </p:nvSpPr>
         <p:spPr>
@@ -4189,7 +4331,7 @@
           <a:p>
             <a:pPr algn="l" indent="0" marL="0">
               <a:lnSpc>
-                <a:spcPct val="125000"/>
+                <a:spcPct val="135000"/>
               </a:lnSpc>
               <a:spcAft>
                 <a:spcPts val="600"/>
@@ -4201,9 +4343,9 @@
                 <a:solidFill>
                   <a:srgbClr val="0E4D49"/>
                 </a:solidFill>
-                <a:latin typeface="PP Mori" pitchFamily="34" charset="0"/>
-                <a:ea typeface="PP Mori" pitchFamily="34" charset="-122"/>
-                <a:cs typeface="PP Mori" pitchFamily="34" charset="-120"/>
+                <a:latin typeface="IBM Plex Serif" pitchFamily="34" charset="0"/>
+                <a:ea typeface="IBM Plex Serif" pitchFamily="34" charset="-122"/>
+                <a:cs typeface="IBM Plex Serif" pitchFamily="34" charset="-120"/>
               </a:rPr>
               <a:t>Businesses in a wide range of industries are increasingly considered responsible not only for their own direct carbon emissions but also for the emissions embodied in their sales products. This whitepaper describes the structure of Integrated Corporate Carbon Accounting (ICCA) systems that track an entity’s direct (Scope 1) and indirect (Scope 2 and upstream Scope 3) emissions over time in order to calculate key carbon emission metrics.</a:t>
             </a:r>
@@ -4212,7 +4354,7 @@
           <a:p>
             <a:pPr algn="l" indent="0" marL="0">
               <a:lnSpc>
-                <a:spcPct val="125000"/>
+                <a:spcPct val="135000"/>
               </a:lnSpc>
               <a:spcAft>
                 <a:spcPts val="600"/>
@@ -4224,9 +4366,9 @@
                 <a:solidFill>
                   <a:srgbClr val="0E4D49"/>
                 </a:solidFill>
-                <a:latin typeface="PP Mori" pitchFamily="34" charset="0"/>
-                <a:ea typeface="PP Mori" pitchFamily="34" charset="-122"/>
-                <a:cs typeface="PP Mori" pitchFamily="34" charset="-120"/>
+                <a:latin typeface="IBM Plex Serif" pitchFamily="34" charset="0"/>
+                <a:ea typeface="IBM Plex Serif" pitchFamily="34" charset="-122"/>
+                <a:cs typeface="IBM Plex Serif" pitchFamily="34" charset="-120"/>
               </a:rPr>
               <a:t>Akin to product costing in financial accounting, ICCA systems determine the cradle-to-gate Product Carbon Footprints (PCFs) of products sold in the current time period on the basis of the company’s actual direct emissions, its operational activities, and the PCFs attributed to production inputs sourced from suppliers. The aggregate PCFs of products sold then become a central building block for determining a company’s periodic Corporate Carbon Footprint (CCF). By separating carbon stock variables from carbon flow variables, ICCA systems track emissions consistently across different time periods. Double-entry bookkeeping enables a particular ICCA architecture that records the carbon stock variables on a CO2 balance sheet, resulting in overall CO2 statements that are structurally similar to financial statements.</a:t>
             </a:r>
@@ -4312,7 +4454,7 @@
           <p:cNvPr id="2" name="Text 0"/>
           <p:cNvSpPr/>
           <p:nvPr>
-            <p:ph idx="100" type="title" hasCustomPrompt="1"/>
+            <p:ph idx="101" type="title" hasCustomPrompt="1"/>
           </p:nvPr>
         </p:nvSpPr>
         <p:spPr>
@@ -4353,7 +4495,7 @@
           <p:cNvPr id="3" name="Text 0"/>
           <p:cNvSpPr/>
           <p:nvPr>
-            <p:ph idx="101" type="body" hasCustomPrompt="1"/>
+            <p:ph idx="102" type="body" hasCustomPrompt="1"/>
           </p:nvPr>
         </p:nvSpPr>
         <p:spPr>
@@ -4373,7 +4515,7 @@
           <a:p>
             <a:pPr algn="l" indent="0" marL="0">
               <a:lnSpc>
-                <a:spcPct val="125000"/>
+                <a:spcPct val="135000"/>
               </a:lnSpc>
               <a:spcAft>
                 <a:spcPts val="600"/>
@@ -4396,7 +4538,7 @@
           <a:p>
             <a:pPr algn="l" indent="0" marL="0">
               <a:lnSpc>
-                <a:spcPct val="125000"/>
+                <a:spcPct val="135000"/>
               </a:lnSpc>
               <a:spcAft>
                 <a:spcPts val="600"/>
@@ -4408,9 +4550,9 @@
                 <a:solidFill>
                   <a:srgbClr val="0E4D49"/>
                 </a:solidFill>
-                <a:latin typeface="PP Mori" pitchFamily="34" charset="0"/>
-                <a:ea typeface="PP Mori" pitchFamily="34" charset="-122"/>
-                <a:cs typeface="PP Mori" pitchFamily="34" charset="-120"/>
+                <a:latin typeface="IBM Plex Serif" pitchFamily="34" charset="0"/>
+                <a:ea typeface="IBM Plex Serif" pitchFamily="34" charset="-122"/>
+                <a:cs typeface="IBM Plex Serif" pitchFamily="34" charset="-120"/>
               </a:rPr>
               <a:t>Companies account and assume responsibility for their own direct (Scope 1) emissions and the indirect emissions embodied in acquired inputs and services (Scope 2 and upstream Scope 3) during an accounting period. An ICCA system is therefore complete if the carbon ledger records all direct and upstream indirect emissions corresponding to incoming goods and services received by the business.</a:t>
             </a:r>
@@ -4423,7 +4565,7 @@
           <p:cNvPr id="4" name="Text 0"/>
           <p:cNvSpPr/>
           <p:nvPr>
-            <p:ph idx="102" type="body" hasCustomPrompt="1"/>
+            <p:ph idx="103" type="body" hasCustomPrompt="1"/>
           </p:nvPr>
         </p:nvSpPr>
         <p:spPr>
@@ -4443,7 +4585,7 @@
           <a:p>
             <a:pPr algn="l" indent="0" marL="0">
               <a:lnSpc>
-                <a:spcPct val="125000"/>
+                <a:spcPct val="135000"/>
               </a:lnSpc>
               <a:spcAft>
                 <a:spcPts val="600"/>
@@ -4466,7 +4608,7 @@
           <a:p>
             <a:pPr algn="l" indent="0" marL="0">
               <a:lnSpc>
-                <a:spcPct val="125000"/>
+                <a:spcPct val="135000"/>
               </a:lnSpc>
               <a:spcAft>
                 <a:spcPts val="600"/>
@@ -4478,9 +4620,9 @@
                 <a:solidFill>
                   <a:srgbClr val="0E4D49"/>
                 </a:solidFill>
-                <a:latin typeface="PP Mori" pitchFamily="34" charset="0"/>
-                <a:ea typeface="PP Mori" pitchFamily="34" charset="-122"/>
-                <a:cs typeface="PP Mori" pitchFamily="34" charset="-120"/>
+                <a:latin typeface="IBM Plex Serif" pitchFamily="34" charset="0"/>
+                <a:ea typeface="IBM Plex Serif" pitchFamily="34" charset="-122"/>
+                <a:cs typeface="IBM Plex Serif" pitchFamily="34" charset="-120"/>
               </a:rPr>
               <a:t>Direct (Scope 1) emissions and direct removals are recorded in the carbon ledger for the accounting period in which they occur. Indirect emissions are recorded in the carbon ledger in the same time period in which customers acquire (take control of) goods and services. The carbon ledger must include accounts for carbon stock variables that capitalize any incoming emissions that are not recorded directly in the current CCF metric.</a:t>
             </a:r>
@@ -4566,7 +4708,7 @@
           <p:cNvPr id="2" name="Text 0"/>
           <p:cNvSpPr/>
           <p:nvPr>
-            <p:ph idx="100" type="title" hasCustomPrompt="1"/>
+            <p:ph idx="101" type="title" hasCustomPrompt="1"/>
           </p:nvPr>
         </p:nvSpPr>
         <p:spPr>
@@ -4604,7 +4746,7 @@
       </p:sp>
       <p:sp>
         <p:nvSpPr>
-          <p:cNvPr id="3" name="Text 1"/>
+          <p:cNvPr id="3" name="Text 0"/>
           <p:cNvSpPr/>
           <p:nvPr>
             <p:ph idx="102" type="body" hasCustomPrompt="1"/>
@@ -4612,8 +4754,8 @@
         </p:nvSpPr>
         <p:spPr>
           <a:xfrm>
-            <a:off x="886968" y="1234440"/>
-            <a:ext cx="10417759" cy="4892040"/>
+            <a:off x="612648" y="960120"/>
+            <a:ext cx="6760159" cy="5440680"/>
           </a:xfrm>
           <a:prstGeom prst="rect">
             <a:avLst/>
@@ -4627,7 +4769,7 @@
           <a:p>
             <a:pPr algn="l" indent="0" marL="0">
               <a:lnSpc>
-                <a:spcPct val="125000"/>
+                <a:spcPct val="135000"/>
               </a:lnSpc>
               <a:spcAft>
                 <a:spcPts val="600"/>
@@ -4639,11 +4781,66 @@
                 <a:solidFill>
                   <a:srgbClr val="0E4D49"/>
                 </a:solidFill>
-                <a:latin typeface="PP Mori" pitchFamily="34" charset="0"/>
-                <a:ea typeface="PP Mori" pitchFamily="34" charset="-122"/>
-                <a:cs typeface="PP Mori" pitchFamily="34" charset="-120"/>
+                <a:latin typeface="IBM Plex Serif" pitchFamily="34" charset="0"/>
+                <a:ea typeface="IBM Plex Serif" pitchFamily="34" charset="-122"/>
+                <a:cs typeface="IBM Plex Serif" pitchFamily="34" charset="-120"/>
               </a:rPr>
               <a:t>This whitepaper provides the foundational statement for a newly formed initiative, termed the Carbon Accounting Standards Initiative (CASI). We are a working group of company representatives and academics from the fields of accounting, corporate reporting, and climate sustainability. We are united by the belief that effective decarbonization depends on reliable investor-grade emissions data and that the principles of financial accounting offer a useful foundation for reliable carbon accounting at the corporate level. Ultimately, corporate carbon accounting must evolve to the point where emissions are tracked, allocated, and reported with the same rigor and structure as financial transactions.</a:t>
+            </a:r>
+            <a:endParaRPr lang="en-US" sz="1200" dirty="0"/>
+          </a:p>
+        </p:txBody>
+      </p:sp>
+      <p:sp>
+        <p:nvSpPr>
+          <p:cNvPr id="4" name="Text 0"/>
+          <p:cNvSpPr/>
+          <p:nvPr>
+            <p:ph idx="103" type="body" hasCustomPrompt="1"/>
+          </p:nvPr>
+        </p:nvSpPr>
+        <p:spPr>
+          <a:xfrm>
+            <a:off x="7738567" y="960120"/>
+            <a:ext cx="3840480" cy="3563874"/>
+          </a:xfrm>
+          <a:prstGeom prst="roundRect">
+            <a:avLst>
+              <a:gd name="adj" fmla="val 4000"/>
+            </a:avLst>
+          </a:prstGeom>
+          <a:solidFill>
+            <a:srgbClr val="EEF2F1"/>
+          </a:solidFill>
+          <a:ln>
+            <a:noFill/>
+          </a:ln>
+        </p:spPr>
+        <p:txBody>
+          <a:bodyPr wrap="square" lIns="274320" tIns="274320" rIns="274320" bIns="274320" rtlCol="0" anchor="t">
+            <a:spAutoFit/>
+          </a:bodyPr>
+          <a:lstStyle/>
+          <a:p>
+            <a:pPr algn="l" indent="0" marL="0">
+              <a:lnSpc>
+                <a:spcPct val="135000"/>
+              </a:lnSpc>
+              <a:spcAft>
+                <a:spcPts val="600"/>
+              </a:spcAft>
+              <a:buNone/>
+            </a:pPr>
+            <a:r>
+              <a:rPr lang="en-US" sz="1200" dirty="0">
+                <a:solidFill>
+                  <a:srgbClr val="0E4D49"/>
+                </a:solidFill>
+                <a:latin typeface="IBM Plex Serif" pitchFamily="34" charset="0"/>
+                <a:ea typeface="IBM Plex Serif" pitchFamily="34" charset="-122"/>
+                <a:cs typeface="IBM Plex Serif" pitchFamily="34" charset="-120"/>
+              </a:rPr>
+              <a:t>In this first whitepaper we introduce the framework of Integrated Corporate Carbon Accounting (ICCA). Such accounting systems ensure that product-level carbon footprints (PCFs) seamlessly integrate with company-level carbon footprints (CCFs). Unlike existing approaches, ICCA applies rigorous accounting logic to GHG emissions and offsets, thereby enabling a coherent, reconcilable, and audit-ready infrastructure for carbon reporting.</a:t>
             </a:r>
             <a:endParaRPr lang="en-US" sz="1200" dirty="0"/>
           </a:p>
@@ -4727,7 +4924,7 @@
           <p:cNvPr id="2" name="Text 0"/>
           <p:cNvSpPr/>
           <p:nvPr>
-            <p:ph idx="100" type="title" hasCustomPrompt="1"/>
+            <p:ph idx="101" type="title" hasCustomPrompt="1"/>
           </p:nvPr>
         </p:nvSpPr>
         <p:spPr>
@@ -4765,30 +4962,38 @@
       </p:sp>
       <p:sp>
         <p:nvSpPr>
-          <p:cNvPr id="3" name="Text 2"/>
+          <p:cNvPr id="3" name="Text 0"/>
           <p:cNvSpPr/>
           <p:nvPr>
-            <p:ph idx="103" type="body" hasCustomPrompt="1"/>
-          </p:nvPr>
-        </p:nvSpPr>
-        <p:spPr>
-          <a:xfrm>
-            <a:off x="886968" y="1234440"/>
-            <a:ext cx="4751680" cy="4892040"/>
-          </a:xfrm>
-          <a:prstGeom prst="rect">
-            <a:avLst/>
-          </a:prstGeom>
-          <a:noFill/>
-          <a:ln/>
-        </p:spPr>
-        <p:txBody>
-          <a:bodyPr wrap="square" lIns="0" tIns="0" rIns="0" bIns="0" rtlCol="0" anchor="t"/>
+            <p:ph idx="102" type="body" hasCustomPrompt="1"/>
+          </p:nvPr>
+        </p:nvSpPr>
+        <p:spPr>
+          <a:xfrm>
+            <a:off x="612648" y="960120"/>
+            <a:ext cx="5300320" cy="2837688"/>
+          </a:xfrm>
+          <a:prstGeom prst="roundRect">
+            <a:avLst>
+              <a:gd name="adj" fmla="val 4000"/>
+            </a:avLst>
+          </a:prstGeom>
+          <a:solidFill>
+            <a:srgbClr val="EEF2F1"/>
+          </a:solidFill>
+          <a:ln>
+            <a:noFill/>
+          </a:ln>
+        </p:spPr>
+        <p:txBody>
+          <a:bodyPr wrap="square" lIns="274320" tIns="274320" rIns="274320" bIns="274320" rtlCol="0" anchor="t">
+            <a:spAutoFit/>
+          </a:bodyPr>
           <a:lstStyle/>
           <a:p>
             <a:pPr algn="l" indent="0" marL="0">
               <a:lnSpc>
-                <a:spcPct val="125000"/>
+                <a:spcPct val="135000"/>
               </a:lnSpc>
               <a:spcAft>
                 <a:spcPts val="600"/>
@@ -4811,7 +5016,7 @@
           <a:p>
             <a:pPr algn="l" indent="0" marL="0">
               <a:lnSpc>
-                <a:spcPct val="125000"/>
+                <a:spcPct val="135000"/>
               </a:lnSpc>
               <a:spcAft>
                 <a:spcPts val="600"/>
@@ -4823,9 +5028,9 @@
                 <a:solidFill>
                   <a:srgbClr val="0E4D49"/>
                 </a:solidFill>
-                <a:latin typeface="PP Mori" pitchFamily="34" charset="0"/>
-                <a:ea typeface="PP Mori" pitchFamily="34" charset="-122"/>
-                <a:cs typeface="PP Mori" pitchFamily="34" charset="-120"/>
+                <a:latin typeface="IBM Plex Serif" pitchFamily="34" charset="0"/>
+                <a:ea typeface="IBM Plex Serif" pitchFamily="34" charset="-122"/>
+                <a:cs typeface="IBM Plex Serif" pitchFamily="34" charset="-120"/>
               </a:rPr>
               <a:t>ICCA systems become more accurate as data inputs about indirect supply chain emissions are increasingly based on primary data that represent the actual emissions incurred in the supply chain. Accuracy will therefore improve as more companies in an entity’s supply network adopt their own ICCA systems. Recent contributions have proposed to quantify the level of accuracy by means of a Data Quality Scoring (DQS) index.</a:t>
             </a:r>
@@ -4835,30 +5040,38 @@
       </p:sp>
       <p:sp>
         <p:nvSpPr>
-          <p:cNvPr id="4" name="Text 2"/>
+          <p:cNvPr id="4" name="Text 0"/>
           <p:cNvSpPr/>
           <p:nvPr>
-            <p:ph idx="104" type="body" hasCustomPrompt="1"/>
-          </p:nvPr>
-        </p:nvSpPr>
-        <p:spPr>
-          <a:xfrm>
-            <a:off x="6553048" y="1234440"/>
-            <a:ext cx="4751680" cy="4892040"/>
-          </a:xfrm>
-          <a:prstGeom prst="rect">
-            <a:avLst/>
-          </a:prstGeom>
-          <a:noFill/>
-          <a:ln/>
-        </p:spPr>
-        <p:txBody>
-          <a:bodyPr wrap="square" lIns="0" tIns="0" rIns="0" bIns="0" rtlCol="0" anchor="t"/>
+            <p:ph idx="103" type="body" hasCustomPrompt="1"/>
+          </p:nvPr>
+        </p:nvSpPr>
+        <p:spPr>
+          <a:xfrm>
+            <a:off x="6278728" y="960120"/>
+            <a:ext cx="5300320" cy="4442460"/>
+          </a:xfrm>
+          <a:prstGeom prst="roundRect">
+            <a:avLst>
+              <a:gd name="adj" fmla="val 4000"/>
+            </a:avLst>
+          </a:prstGeom>
+          <a:solidFill>
+            <a:srgbClr val="EEF2F1"/>
+          </a:solidFill>
+          <a:ln>
+            <a:noFill/>
+          </a:ln>
+        </p:spPr>
+        <p:txBody>
+          <a:bodyPr wrap="square" lIns="274320" tIns="274320" rIns="274320" bIns="274320" rtlCol="0" anchor="t">
+            <a:spAutoFit/>
+          </a:bodyPr>
           <a:lstStyle/>
           <a:p>
             <a:pPr algn="l" indent="0" marL="0">
               <a:lnSpc>
-                <a:spcPct val="125000"/>
+                <a:spcPct val="135000"/>
               </a:lnSpc>
               <a:spcAft>
                 <a:spcPts val="600"/>
@@ -4881,7 +5094,7 @@
           <a:p>
             <a:pPr algn="l" indent="0" marL="0">
               <a:lnSpc>
-                <a:spcPct val="125000"/>
+                <a:spcPct val="135000"/>
               </a:lnSpc>
               <a:spcAft>
                 <a:spcPts val="600"/>
@@ -4893,9 +5106,9 @@
                 <a:solidFill>
                   <a:srgbClr val="0E4D49"/>
                 </a:solidFill>
-                <a:latin typeface="PP Mori" pitchFamily="34" charset="0"/>
-                <a:ea typeface="PP Mori" pitchFamily="34" charset="-122"/>
-                <a:cs typeface="PP Mori" pitchFamily="34" charset="-120"/>
+                <a:latin typeface="IBM Plex Serif" pitchFamily="34" charset="0"/>
+                <a:ea typeface="IBM Plex Serif" pitchFamily="34" charset="-122"/>
+                <a:cs typeface="IBM Plex Serif" pitchFamily="34" charset="-120"/>
               </a:rPr>
               <a:t>In most industries, the calculation of CCFs and PCFs requires pools of overhead emissions to be prorated (allocated) among different time periods and products. Such pools of overhead emissions frequently emerge in connection with shared assets or consumable inputs (e.g., electricity) that are used by multiple products. The principle of unbiasedness requires the applicable allocation rules to capture the causal link between emissions associated with specific production activities and the extent to which different products require these activities. While allocation rules that reflect the underlying causal links are intended to limit selective greenwashing, companies will generally retain some discretion in choosing among alternative allocation rules which meet this criterion.</a:t>
             </a:r>
@@ -4981,7 +5194,7 @@
           <p:cNvPr id="2" name="Text 0"/>
           <p:cNvSpPr/>
           <p:nvPr>
-            <p:ph idx="100" type="title" hasCustomPrompt="1"/>
+            <p:ph idx="101" type="title" hasCustomPrompt="1"/>
           </p:nvPr>
         </p:nvSpPr>
         <p:spPr>
@@ -5046,7 +5259,7 @@
           <p:cNvPr id="4" name="Text 0"/>
           <p:cNvSpPr/>
           <p:nvPr>
-            <p:ph idx="102" type="body" hasCustomPrompt="1"/>
+            <p:ph idx="103" type="body" hasCustomPrompt="1"/>
           </p:nvPr>
         </p:nvSpPr>
         <p:spPr>
@@ -5068,9 +5281,6 @@
               <a:lnSpc>
                 <a:spcPct val="120000"/>
               </a:lnSpc>
-              <a:spcAft>
-                <a:spcPts val="600"/>
-              </a:spcAft>
               <a:buNone/>
             </a:pPr>
             <a:r>
@@ -5093,7 +5303,7 @@
           <p:cNvPr id="5" name="Text 0"/>
           <p:cNvSpPr/>
           <p:nvPr>
-            <p:ph idx="101" hasCustomPrompt="1"/>
+            <p:ph idx="102" hasCustomPrompt="1"/>
           </p:nvPr>
         </p:nvSpPr>
         <p:spPr>
@@ -5196,7 +5406,7 @@
           <p:cNvPr id="2" name="Text 1"/>
           <p:cNvSpPr/>
           <p:nvPr>
-            <p:ph idx="101" type="title" hasCustomPrompt="1"/>
+            <p:ph idx="102" type="title" hasCustomPrompt="1"/>
           </p:nvPr>
         </p:nvSpPr>
         <p:spPr>
@@ -5240,7 +5450,7 @@
           <p:cNvPr id="3" name="Text 1"/>
           <p:cNvSpPr/>
           <p:nvPr>
-            <p:ph idx="102" type="body" hasCustomPrompt="1"/>
+            <p:ph idx="103" type="body" hasCustomPrompt="1"/>
           </p:nvPr>
         </p:nvSpPr>
         <p:spPr>
@@ -5260,11 +5470,8 @@
           <a:p>
             <a:pPr algn="l" indent="0" marL="0">
               <a:lnSpc>
-                <a:spcPct val="125000"/>
+                <a:spcPct val="135000"/>
               </a:lnSpc>
-              <a:spcAft>
-                <a:spcPts val="600"/>
-              </a:spcAft>
               <a:buNone/>
             </a:pPr>
             <a:r>
@@ -5283,11 +5490,8 @@
           <a:p>
             <a:pPr algn="l" indent="0" marL="0">
               <a:lnSpc>
-                <a:spcPct val="125000"/>
+                <a:spcPct val="135000"/>
               </a:lnSpc>
-              <a:spcAft>
-                <a:spcPts val="600"/>
-              </a:spcAft>
               <a:buNone/>
             </a:pPr>
             <a:r>

</xml_diff>

<commit_message>
Folien: kein kleines Logo mehr auf Inhaltsfolien, Boxhöhen nach PowerPoint-Zeilenabstand, Boxen nebeneinander gleich hoch
Co-Authored-By: Claude Opus 5.5 <noreply@anthropic.com>
Claude-Session: https://claude.ai/code/session_013CPr38Ajq4U6Bb9Du7X7Xh
</commit_message>
<xml_diff>
--- a/vorlagen/CASI-Folien-Beispiel.pptx
+++ b/vorlagen/CASI-Folien-Beispiel.pptx
@@ -1786,30 +1786,6 @@
           <a:chExt cx="0" cy="0"/>
         </a:xfrm>
       </p:grpSpPr>
-      <p:pic>
-        <p:nvPicPr>
-          <p:cNvPr id="2" name="Image 0" descr="CASI">    </p:cNvPr>
-          <p:cNvPicPr>
-            <a:picLocks noChangeAspect="1"/>
-          </p:cNvPicPr>
-          <p:nvPr/>
-        </p:nvPicPr>
-        <p:blipFill>
-          <a:blip r:embed="rId1"/>
-          <a:stretch>
-            <a:fillRect/>
-          </a:stretch>
-        </p:blipFill>
-        <p:spPr>
-          <a:xfrm>
-            <a:off x="612648" y="6437376"/>
-            <a:ext cx="163220" cy="182880"/>
-          </a:xfrm>
-          <a:prstGeom prst="rect">
-            <a:avLst/>
-          </a:prstGeom>
-        </p:spPr>
-      </p:pic>
       <p:sp>
         <p:nvSpPr>
           <p:cNvPr id="25" name="Slide Number Placeholder 0"/>
@@ -2182,36 +2158,12 @@
           <a:chExt cx="0" cy="0"/>
         </a:xfrm>
       </p:grpSpPr>
-      <p:pic>
-        <p:nvPicPr>
-          <p:cNvPr id="2" name="Image 0" descr="CASI">    </p:cNvPr>
-          <p:cNvPicPr>
-            <a:picLocks noChangeAspect="1"/>
-          </p:cNvPicPr>
-          <p:nvPr/>
-        </p:nvPicPr>
-        <p:blipFill>
-          <a:blip r:embed="rId1"/>
-          <a:stretch>
-            <a:fillRect/>
-          </a:stretch>
-        </p:blipFill>
-        <p:spPr>
-          <a:xfrm>
-            <a:off x="612648" y="6437376"/>
-            <a:ext cx="163220" cy="182880"/>
-          </a:xfrm>
-          <a:prstGeom prst="rect">
-            <a:avLst/>
-          </a:prstGeom>
-        </p:spPr>
-      </p:pic>
-      <p:sp>
-        <p:nvSpPr>
-          <p:cNvPr id="3" name="Text 0"/>
+      <p:sp>
+        <p:nvSpPr>
+          <p:cNvPr id="2" name="Text 0"/>
           <p:cNvSpPr/>
           <p:nvPr>
-            <p:ph idx="101" type="body" hasCustomPrompt="1"/>
+            <p:ph idx="100" type="body" hasCustomPrompt="1"/>
           </p:nvPr>
         </p:nvSpPr>
         <p:spPr>
@@ -2267,10 +2219,10 @@
       </p:sp>
       <p:sp>
         <p:nvSpPr>
-          <p:cNvPr id="4" name="Text 0"/>
+          <p:cNvPr id="3" name="Text 0"/>
           <p:cNvSpPr/>
           <p:nvPr>
-            <p:ph idx="102" type="title" hasCustomPrompt="1"/>
+            <p:ph idx="101" type="title" hasCustomPrompt="1"/>
           </p:nvPr>
         </p:nvSpPr>
         <p:spPr>
@@ -2404,36 +2356,12 @@
           <a:chExt cx="0" cy="0"/>
         </a:xfrm>
       </p:grpSpPr>
-      <p:pic>
-        <p:nvPicPr>
-          <p:cNvPr id="2" name="Image 0" descr="CASI">    </p:cNvPr>
-          <p:cNvPicPr>
-            <a:picLocks noChangeAspect="1"/>
-          </p:cNvPicPr>
-          <p:nvPr/>
-        </p:nvPicPr>
-        <p:blipFill>
-          <a:blip r:embed="rId1"/>
-          <a:stretch>
-            <a:fillRect/>
-          </a:stretch>
-        </p:blipFill>
-        <p:spPr>
-          <a:xfrm>
-            <a:off x="612648" y="6437376"/>
-            <a:ext cx="163220" cy="182880"/>
-          </a:xfrm>
-          <a:prstGeom prst="rect">
-            <a:avLst/>
-          </a:prstGeom>
-        </p:spPr>
-      </p:pic>
-      <p:sp>
-        <p:nvSpPr>
-          <p:cNvPr id="3" name="Text 0"/>
+      <p:sp>
+        <p:nvSpPr>
+          <p:cNvPr id="2" name="Text 0"/>
           <p:cNvSpPr/>
           <p:nvPr>
-            <p:ph idx="101" type="title" hasCustomPrompt="1"/>
+            <p:ph idx="100" type="title" hasCustomPrompt="1"/>
           </p:nvPr>
         </p:nvSpPr>
         <p:spPr>
@@ -2483,10 +2411,10 @@
       </p:sp>
       <p:sp>
         <p:nvSpPr>
-          <p:cNvPr id="4" name="Text 0"/>
+          <p:cNvPr id="3" name="Text 0"/>
           <p:cNvSpPr/>
           <p:nvPr>
-            <p:ph idx="102" type="body" hasCustomPrompt="1"/>
+            <p:ph idx="101" type="body" hasCustomPrompt="1"/>
           </p:nvPr>
         </p:nvSpPr>
         <p:spPr>
@@ -2626,36 +2554,12 @@
           <a:chExt cx="0" cy="0"/>
         </a:xfrm>
       </p:grpSpPr>
-      <p:pic>
-        <p:nvPicPr>
-          <p:cNvPr id="2" name="Image 0" descr="CASI">    </p:cNvPr>
-          <p:cNvPicPr>
-            <a:picLocks noChangeAspect="1"/>
-          </p:cNvPicPr>
-          <p:nvPr/>
-        </p:nvPicPr>
-        <p:blipFill>
-          <a:blip r:embed="rId1"/>
-          <a:stretch>
-            <a:fillRect/>
-          </a:stretch>
-        </p:blipFill>
-        <p:spPr>
-          <a:xfrm>
-            <a:off x="612648" y="6437376"/>
-            <a:ext cx="163220" cy="182880"/>
-          </a:xfrm>
-          <a:prstGeom prst="rect">
-            <a:avLst/>
-          </a:prstGeom>
-        </p:spPr>
-      </p:pic>
-      <p:sp>
-        <p:nvSpPr>
-          <p:cNvPr id="3" name="Text 0"/>
+      <p:sp>
+        <p:nvSpPr>
+          <p:cNvPr id="2" name="Text 0"/>
           <p:cNvSpPr/>
           <p:nvPr>
-            <p:ph idx="101" type="title" hasCustomPrompt="1"/>
+            <p:ph idx="100" type="title" hasCustomPrompt="1"/>
           </p:nvPr>
         </p:nvSpPr>
         <p:spPr>
@@ -2783,36 +2687,12 @@
           <a:chExt cx="0" cy="0"/>
         </a:xfrm>
       </p:grpSpPr>
-      <p:pic>
-        <p:nvPicPr>
-          <p:cNvPr id="2" name="Image 0" descr="CASI">    </p:cNvPr>
-          <p:cNvPicPr>
-            <a:picLocks noChangeAspect="1"/>
-          </p:cNvPicPr>
-          <p:nvPr/>
-        </p:nvPicPr>
-        <p:blipFill>
-          <a:blip r:embed="rId1"/>
-          <a:stretch>
-            <a:fillRect/>
-          </a:stretch>
-        </p:blipFill>
-        <p:spPr>
-          <a:xfrm>
-            <a:off x="612648" y="6437376"/>
-            <a:ext cx="163220" cy="182880"/>
-          </a:xfrm>
-          <a:prstGeom prst="rect">
-            <a:avLst/>
-          </a:prstGeom>
-        </p:spPr>
-      </p:pic>
-      <p:sp>
-        <p:nvSpPr>
-          <p:cNvPr id="3" name="Text 0"/>
+      <p:sp>
+        <p:nvSpPr>
+          <p:cNvPr id="2" name="Text 0"/>
           <p:cNvSpPr/>
           <p:nvPr>
-            <p:ph idx="101" type="title" hasCustomPrompt="1"/>
+            <p:ph idx="100" type="title" hasCustomPrompt="1"/>
           </p:nvPr>
         </p:nvSpPr>
         <p:spPr>
@@ -2862,10 +2742,10 @@
       </p:sp>
       <p:sp>
         <p:nvSpPr>
-          <p:cNvPr id="4" name="Text 0"/>
+          <p:cNvPr id="3" name="Text 0"/>
           <p:cNvSpPr/>
           <p:nvPr>
-            <p:ph idx="102" type="body" hasCustomPrompt="1"/>
+            <p:ph idx="101" type="body" hasCustomPrompt="1"/>
           </p:nvPr>
         </p:nvSpPr>
         <p:spPr>
@@ -2927,10 +2807,10 @@
       </p:sp>
       <p:sp>
         <p:nvSpPr>
-          <p:cNvPr id="5" name="Text 0"/>
+          <p:cNvPr id="4" name="Text 0"/>
           <p:cNvSpPr/>
           <p:nvPr>
-            <p:ph idx="103" type="body" hasCustomPrompt="1"/>
+            <p:ph idx="102" type="body" hasCustomPrompt="1"/>
           </p:nvPr>
         </p:nvSpPr>
         <p:spPr>
@@ -3070,36 +2950,12 @@
           <a:chExt cx="0" cy="0"/>
         </a:xfrm>
       </p:grpSpPr>
-      <p:pic>
-        <p:nvPicPr>
-          <p:cNvPr id="2" name="Image 0" descr="CASI">    </p:cNvPr>
-          <p:cNvPicPr>
-            <a:picLocks noChangeAspect="1"/>
-          </p:cNvPicPr>
-          <p:nvPr/>
-        </p:nvPicPr>
-        <p:blipFill>
-          <a:blip r:embed="rId1"/>
-          <a:stretch>
-            <a:fillRect/>
-          </a:stretch>
-        </p:blipFill>
-        <p:spPr>
-          <a:xfrm>
-            <a:off x="612648" y="6437376"/>
-            <a:ext cx="163220" cy="182880"/>
-          </a:xfrm>
-          <a:prstGeom prst="rect">
-            <a:avLst/>
-          </a:prstGeom>
-        </p:spPr>
-      </p:pic>
-      <p:sp>
-        <p:nvSpPr>
-          <p:cNvPr id="3" name="Text 0"/>
+      <p:sp>
+        <p:nvSpPr>
+          <p:cNvPr id="2" name="Text 0"/>
           <p:cNvSpPr/>
           <p:nvPr>
-            <p:ph idx="101" type="title" hasCustomPrompt="1"/>
+            <p:ph idx="100" type="title" hasCustomPrompt="1"/>
           </p:nvPr>
         </p:nvSpPr>
         <p:spPr>
@@ -3149,10 +3005,10 @@
       </p:sp>
       <p:sp>
         <p:nvSpPr>
-          <p:cNvPr id="4" name="Text 0"/>
+          <p:cNvPr id="3" name="Text 0"/>
           <p:cNvSpPr/>
           <p:nvPr>
-            <p:ph idx="102" type="body" hasCustomPrompt="1"/>
+            <p:ph idx="101" type="body" hasCustomPrompt="1"/>
           </p:nvPr>
         </p:nvSpPr>
         <p:spPr>
@@ -3214,10 +3070,10 @@
       </p:sp>
       <p:sp>
         <p:nvSpPr>
-          <p:cNvPr id="5" name="Text 0"/>
+          <p:cNvPr id="4" name="Text 0"/>
           <p:cNvSpPr/>
           <p:nvPr>
-            <p:ph idx="103" type="body" hasCustomPrompt="1"/>
+            <p:ph idx="102" type="body" hasCustomPrompt="1"/>
           </p:nvPr>
         </p:nvSpPr>
         <p:spPr>
@@ -3365,36 +3221,12 @@
           <a:chExt cx="0" cy="0"/>
         </a:xfrm>
       </p:grpSpPr>
-      <p:pic>
-        <p:nvPicPr>
-          <p:cNvPr id="2" name="Image 0" descr="CASI">    </p:cNvPr>
-          <p:cNvPicPr>
-            <a:picLocks noChangeAspect="1"/>
-          </p:cNvPicPr>
-          <p:nvPr/>
-        </p:nvPicPr>
-        <p:blipFill>
-          <a:blip r:embed="rId1"/>
-          <a:stretch>
-            <a:fillRect/>
-          </a:stretch>
-        </p:blipFill>
-        <p:spPr>
-          <a:xfrm>
-            <a:off x="612648" y="6437376"/>
-            <a:ext cx="163220" cy="182880"/>
-          </a:xfrm>
-          <a:prstGeom prst="rect">
-            <a:avLst/>
-          </a:prstGeom>
-        </p:spPr>
-      </p:pic>
-      <p:sp>
-        <p:nvSpPr>
-          <p:cNvPr id="3" name="Text 0"/>
+      <p:sp>
+        <p:nvSpPr>
+          <p:cNvPr id="2" name="Text 0"/>
           <p:cNvSpPr/>
           <p:nvPr>
-            <p:ph idx="101" type="title" hasCustomPrompt="1"/>
+            <p:ph idx="100" type="title" hasCustomPrompt="1"/>
           </p:nvPr>
         </p:nvSpPr>
         <p:spPr>
@@ -3444,10 +3276,10 @@
       </p:sp>
       <p:sp>
         <p:nvSpPr>
-          <p:cNvPr id="4" name="Text 0"/>
+          <p:cNvPr id="3" name="Text 0"/>
           <p:cNvSpPr/>
           <p:nvPr>
-            <p:ph idx="102" type="body" hasCustomPrompt="1"/>
+            <p:ph idx="101" type="body" hasCustomPrompt="1"/>
           </p:nvPr>
         </p:nvSpPr>
         <p:spPr>
@@ -3517,10 +3349,10 @@
       </p:sp>
       <p:sp>
         <p:nvSpPr>
-          <p:cNvPr id="5" name="Text 0"/>
+          <p:cNvPr id="4" name="Text 0"/>
           <p:cNvSpPr/>
           <p:nvPr>
-            <p:ph idx="103" type="body" hasCustomPrompt="1"/>
+            <p:ph idx="102" type="body" hasCustomPrompt="1"/>
           </p:nvPr>
         </p:nvSpPr>
         <p:spPr>
@@ -3668,36 +3500,12 @@
           <a:chExt cx="0" cy="0"/>
         </a:xfrm>
       </p:grpSpPr>
-      <p:pic>
-        <p:nvPicPr>
-          <p:cNvPr id="2" name="Image 0" descr="CASI">    </p:cNvPr>
-          <p:cNvPicPr>
-            <a:picLocks noChangeAspect="1"/>
-          </p:cNvPicPr>
-          <p:nvPr/>
-        </p:nvPicPr>
-        <p:blipFill>
-          <a:blip r:embed="rId1"/>
-          <a:stretch>
-            <a:fillRect/>
-          </a:stretch>
-        </p:blipFill>
-        <p:spPr>
-          <a:xfrm>
-            <a:off x="612648" y="6437376"/>
-            <a:ext cx="163220" cy="182880"/>
-          </a:xfrm>
-          <a:prstGeom prst="rect">
-            <a:avLst/>
-          </a:prstGeom>
-        </p:spPr>
-      </p:pic>
-      <p:sp>
-        <p:nvSpPr>
-          <p:cNvPr id="3" name="Text 0"/>
+      <p:sp>
+        <p:nvSpPr>
+          <p:cNvPr id="2" name="Text 0"/>
           <p:cNvSpPr/>
           <p:nvPr>
-            <p:ph idx="101" type="title" hasCustomPrompt="1"/>
+            <p:ph idx="100" type="title" hasCustomPrompt="1"/>
           </p:nvPr>
         </p:nvSpPr>
         <p:spPr>
@@ -3747,10 +3555,10 @@
       </p:sp>
       <p:sp>
         <p:nvSpPr>
-          <p:cNvPr id="4" name="Text 0"/>
+          <p:cNvPr id="3" name="Text 0"/>
           <p:cNvSpPr/>
           <p:nvPr>
-            <p:ph idx="102" hasCustomPrompt="1"/>
+            <p:ph idx="101" hasCustomPrompt="1"/>
           </p:nvPr>
         </p:nvSpPr>
         <p:spPr>
@@ -3794,10 +3602,10 @@
       </p:sp>
       <p:sp>
         <p:nvSpPr>
-          <p:cNvPr id="5" name="Text 0"/>
+          <p:cNvPr id="4" name="Text 0"/>
           <p:cNvSpPr/>
           <p:nvPr>
-            <p:ph idx="103" type="body" hasCustomPrompt="1"/>
+            <p:ph idx="102" type="body" hasCustomPrompt="1"/>
           </p:nvPr>
         </p:nvSpPr>
         <p:spPr>
@@ -4465,7 +4273,7 @@
           <p:cNvPr id="2" name="Text 0"/>
           <p:cNvSpPr/>
           <p:nvPr>
-            <p:ph idx="101" type="title" hasCustomPrompt="1"/>
+            <p:ph idx="100" type="title" hasCustomPrompt="1"/>
           </p:nvPr>
         </p:nvSpPr>
         <p:spPr>
@@ -6322,7 +6130,7 @@
           <p:cNvPr id="2" name="Text 0"/>
           <p:cNvSpPr/>
           <p:nvPr>
-            <p:ph idx="101" type="title" hasCustomPrompt="1"/>
+            <p:ph idx="100" type="title" hasCustomPrompt="1"/>
           </p:nvPr>
         </p:nvSpPr>
         <p:spPr>
@@ -8307,7 +8115,7 @@
           <p:cNvPr id="2" name="Text 0"/>
           <p:cNvSpPr/>
           <p:nvPr>
-            <p:ph idx="101" type="body" hasCustomPrompt="1"/>
+            <p:ph idx="100" type="body" hasCustomPrompt="1"/>
           </p:nvPr>
         </p:nvSpPr>
         <p:spPr>
@@ -8351,7 +8159,7 @@
           <p:cNvPr id="3" name="Text 0"/>
           <p:cNvSpPr/>
           <p:nvPr>
-            <p:ph idx="102" type="title" hasCustomPrompt="1"/>
+            <p:ph idx="101" type="title" hasCustomPrompt="1"/>
           </p:nvPr>
         </p:nvSpPr>
         <p:spPr>
@@ -8468,7 +8276,7 @@
           <p:cNvPr id="2" name="Text 0"/>
           <p:cNvSpPr/>
           <p:nvPr>
-            <p:ph idx="101" type="title" hasCustomPrompt="1"/>
+            <p:ph idx="100" type="title" hasCustomPrompt="1"/>
           </p:nvPr>
         </p:nvSpPr>
         <p:spPr>
@@ -8509,7 +8317,7 @@
           <p:cNvPr id="3" name="Text 0"/>
           <p:cNvSpPr/>
           <p:nvPr>
-            <p:ph idx="102" type="body" hasCustomPrompt="1"/>
+            <p:ph idx="101" type="body" hasCustomPrompt="1"/>
           </p:nvPr>
         </p:nvSpPr>
         <p:spPr>
@@ -8652,7 +8460,7 @@
           <p:cNvPr id="2" name="Text 0"/>
           <p:cNvSpPr/>
           <p:nvPr>
-            <p:ph idx="101" type="title" hasCustomPrompt="1"/>
+            <p:ph idx="100" type="title" hasCustomPrompt="1"/>
           </p:nvPr>
         </p:nvSpPr>
         <p:spPr>
@@ -8693,7 +8501,7 @@
           <p:cNvPr id="3" name="Text 0"/>
           <p:cNvSpPr/>
           <p:nvPr>
-            <p:ph idx="102" type="body" hasCustomPrompt="1"/>
+            <p:ph idx="101" type="body" hasCustomPrompt="1"/>
           </p:nvPr>
         </p:nvSpPr>
         <p:spPr>
@@ -8763,7 +8571,7 @@
           <p:cNvPr id="4" name="Text 0"/>
           <p:cNvSpPr/>
           <p:nvPr>
-            <p:ph idx="103" type="body" hasCustomPrompt="1"/>
+            <p:ph idx="102" type="body" hasCustomPrompt="1"/>
           </p:nvPr>
         </p:nvSpPr>
         <p:spPr>
@@ -8906,7 +8714,7 @@
           <p:cNvPr id="2" name="Text 0"/>
           <p:cNvSpPr/>
           <p:nvPr>
-            <p:ph idx="101" type="title" hasCustomPrompt="1"/>
+            <p:ph idx="100" type="title" hasCustomPrompt="1"/>
           </p:nvPr>
         </p:nvSpPr>
         <p:spPr>
@@ -8947,7 +8755,7 @@
           <p:cNvPr id="3" name="Text 0"/>
           <p:cNvSpPr/>
           <p:nvPr>
-            <p:ph idx="102" type="body" hasCustomPrompt="1"/>
+            <p:ph idx="101" type="body" hasCustomPrompt="1"/>
           </p:nvPr>
         </p:nvSpPr>
         <p:spPr>
@@ -8994,13 +8802,13 @@
           <p:cNvPr id="4" name="Text 0"/>
           <p:cNvSpPr/>
           <p:nvPr>
-            <p:ph idx="103" type="body" hasCustomPrompt="1"/>
+            <p:ph idx="102" type="body" hasCustomPrompt="1"/>
           </p:nvPr>
         </p:nvSpPr>
         <p:spPr>
           <a:xfrm>
             <a:off x="7738567" y="960120"/>
-            <a:ext cx="3840480" cy="3804406"/>
+            <a:ext cx="3840480" cy="3520440"/>
           </a:xfrm>
           <a:prstGeom prst="roundRect">
             <a:avLst>
@@ -9122,7 +8930,7 @@
           <p:cNvPr id="2" name="Text 0"/>
           <p:cNvSpPr/>
           <p:nvPr>
-            <p:ph idx="101" type="title" hasCustomPrompt="1"/>
+            <p:ph idx="100" type="title" hasCustomPrompt="1"/>
           </p:nvPr>
         </p:nvSpPr>
         <p:spPr>
@@ -9163,13 +8971,13 @@
           <p:cNvPr id="3" name="Text 0"/>
           <p:cNvSpPr/>
           <p:nvPr>
-            <p:ph idx="102" type="body" hasCustomPrompt="1"/>
+            <p:ph idx="101" type="body" hasCustomPrompt="1"/>
           </p:nvPr>
         </p:nvSpPr>
         <p:spPr>
           <a:xfrm>
             <a:off x="612648" y="960120"/>
-            <a:ext cx="5300320" cy="3318159"/>
+            <a:ext cx="5300320" cy="4339589"/>
           </a:xfrm>
           <a:prstGeom prst="roundRect">
             <a:avLst>
@@ -9241,13 +9049,13 @@
           <p:cNvPr id="4" name="Text 0"/>
           <p:cNvSpPr/>
           <p:nvPr>
-            <p:ph idx="103" type="body" hasCustomPrompt="1"/>
+            <p:ph idx="102" type="body" hasCustomPrompt="1"/>
           </p:nvPr>
         </p:nvSpPr>
         <p:spPr>
           <a:xfrm>
             <a:off x="6278728" y="960120"/>
-            <a:ext cx="5300320" cy="4735708"/>
+            <a:ext cx="5300320" cy="4339589"/>
           </a:xfrm>
           <a:prstGeom prst="roundRect">
             <a:avLst>
@@ -9392,7 +9200,7 @@
           <p:cNvPr id="2" name="Text 0"/>
           <p:cNvSpPr/>
           <p:nvPr>
-            <p:ph idx="101" type="title" hasCustomPrompt="1"/>
+            <p:ph idx="100" type="title" hasCustomPrompt="1"/>
           </p:nvPr>
         </p:nvSpPr>
         <p:spPr>
@@ -9457,7 +9265,7 @@
           <p:cNvPr id="4" name="Text 0"/>
           <p:cNvSpPr/>
           <p:nvPr>
-            <p:ph idx="103" type="body" hasCustomPrompt="1"/>
+            <p:ph idx="102" type="body" hasCustomPrompt="1"/>
           </p:nvPr>
         </p:nvSpPr>
         <p:spPr>
@@ -9501,7 +9309,7 @@
           <p:cNvPr id="5" name="Text 0"/>
           <p:cNvSpPr/>
           <p:nvPr>
-            <p:ph idx="102" hasCustomPrompt="1"/>
+            <p:ph idx="101" hasCustomPrompt="1"/>
           </p:nvPr>
         </p:nvSpPr>
         <p:spPr>
@@ -9604,7 +9412,7 @@
           <p:cNvPr id="2" name="Text 0"/>
           <p:cNvSpPr/>
           <p:nvPr>
-            <p:ph idx="101" type="title" hasCustomPrompt="1"/>
+            <p:ph idx="100" type="title" hasCustomPrompt="1"/>
           </p:nvPr>
         </p:nvSpPr>
         <p:spPr>
@@ -10875,7 +10683,7 @@
           <p:cNvPr id="2" name="Text 0"/>
           <p:cNvSpPr/>
           <p:nvPr>
-            <p:ph idx="101" type="title" hasCustomPrompt="1"/>
+            <p:ph idx="100" type="title" hasCustomPrompt="1"/>
           </p:nvPr>
         </p:nvSpPr>
         <p:spPr>

</xml_diff>

<commit_message>
Boxen: Ecken oben nicht mehr abgeschnitten (Layout- und Folien-Box mit gleichem Radius 0,1″), Beispielfolien mit fester Höhe
Co-Authored-By: Claude Opus 5.5 <noreply@anthropic.com>
Claude-Session: https://claude.ai/code/session_013CPr38Ajq4U6Bb9Du7X7Xh
</commit_message>
<xml_diff>
--- a/vorlagen/CASI-Folien-Beispiel.pptx
+++ b/vorlagen/CASI-Folien-Beispiel.pptx
@@ -3079,11 +3079,11 @@
         <p:spPr>
           <a:xfrm>
             <a:off x="7738567" y="960120"/>
-            <a:ext cx="3840480" cy="1097280"/>
+            <a:ext cx="3840480" cy="795528"/>
           </a:xfrm>
           <a:prstGeom prst="roundRect">
             <a:avLst>
-              <a:gd name="adj" fmla="val 4000"/>
+              <a:gd name="adj" fmla="val 11494"/>
             </a:avLst>
           </a:prstGeom>
           <a:solidFill>
@@ -3285,11 +3285,11 @@
         <p:spPr>
           <a:xfrm>
             <a:off x="612648" y="960120"/>
-            <a:ext cx="5300320" cy="1097280"/>
+            <a:ext cx="5300320" cy="795528"/>
           </a:xfrm>
           <a:prstGeom prst="roundRect">
             <a:avLst>
-              <a:gd name="adj" fmla="val 4000"/>
+              <a:gd name="adj" fmla="val 11494"/>
             </a:avLst>
           </a:prstGeom>
           <a:solidFill>
@@ -3358,11 +3358,11 @@
         <p:spPr>
           <a:xfrm>
             <a:off x="6278728" y="960120"/>
-            <a:ext cx="5300320" cy="1097280"/>
+            <a:ext cx="5300320" cy="795528"/>
           </a:xfrm>
           <a:prstGeom prst="roundRect">
             <a:avLst>
-              <a:gd name="adj" fmla="val 4000"/>
+              <a:gd name="adj" fmla="val 11494"/>
             </a:avLst>
           </a:prstGeom>
           <a:solidFill>
@@ -8812,7 +8812,7 @@
           </a:xfrm>
           <a:prstGeom prst="roundRect">
             <a:avLst>
-              <a:gd name="adj" fmla="val 4000"/>
+              <a:gd name="adj" fmla="val 2597"/>
             </a:avLst>
           </a:prstGeom>
           <a:solidFill>
@@ -8824,7 +8824,7 @@
         </p:spPr>
         <p:txBody>
           <a:bodyPr wrap="square" lIns="274320" tIns="274320" rIns="274320" bIns="274320" rtlCol="0" anchor="t">
-            <a:spAutoFit/>
+            <a:noAutofit/>
           </a:bodyPr>
           <a:lstStyle/>
           <a:p>
@@ -8981,7 +8981,7 @@
           </a:xfrm>
           <a:prstGeom prst="roundRect">
             <a:avLst>
-              <a:gd name="adj" fmla="val 4000"/>
+              <a:gd name="adj" fmla="val 2107"/>
             </a:avLst>
           </a:prstGeom>
           <a:solidFill>
@@ -8993,7 +8993,7 @@
         </p:spPr>
         <p:txBody>
           <a:bodyPr wrap="square" lIns="274320" tIns="274320" rIns="274320" bIns="274320" rtlCol="0" anchor="t">
-            <a:spAutoFit/>
+            <a:noAutofit/>
           </a:bodyPr>
           <a:lstStyle/>
           <a:p>
@@ -9059,7 +9059,7 @@
           </a:xfrm>
           <a:prstGeom prst="roundRect">
             <a:avLst>
-              <a:gd name="adj" fmla="val 4000"/>
+              <a:gd name="adj" fmla="val 2107"/>
             </a:avLst>
           </a:prstGeom>
           <a:solidFill>
@@ -9071,7 +9071,7 @@
         </p:spPr>
         <p:txBody>
           <a:bodyPr wrap="square" lIns="274320" tIns="274320" rIns="274320" bIns="274320" rtlCol="0" anchor="t">
-            <a:spAutoFit/>
+            <a:noAutofit/>
           </a:bodyPr>
           <a:lstStyle/>
           <a:p>

</xml_diff>

<commit_message>
CI: externe Grafiken bleiben, interne im Stil der Website-Grafiken; Website-Symbole (SVG/PNG), Grafikfarben korrigiert
- neuer Abschnitt Graphics in ci/SKILL.md, Grafik-Regeln in tokens.json
- Symbole unter /marke/symbole/ und als CASI-Symbole.zip im Connector
- Wertschöpfungsketten-Farben nach casi-wp.css (dunklere Fassung), Grafik-Neutraltöne
- PowerPoint-Theme: benutzerdefinierte Farben angepasst

Co-Authored-By: Claude Opus 5.5 <noreply@anthropic.com>
Claude-Session: https://claude.ai/code/session_013CPr38Ajq4U6Bb9Du7X7Xh
</commit_message>
<xml_diff>
--- a/vorlagen/CASI-Folien-Beispiel.pptx
+++ b/vorlagen/CASI-Folien-Beispiel.pptx
@@ -13647,23 +13647,29 @@
     <a:custClr name="Burgundy mittel">
       <a:srgbClr val="CB96A6"/>
     </a:custClr>
-    <a:custClr name="Kette direct">
+    <a:custClr name="Kette iron">
+      <a:srgbClr val="A75F26"/>
+    </a:custClr>
+    <a:custClr name="Kette steel">
+      <a:srgbClr val="1A6685"/>
+    </a:custClr>
+    <a:custClr name="Kette body">
+      <a:srgbClr val="17876F"/>
+    </a:custClr>
+    <a:custClr name="Kette car">
+      <a:srgbClr val="2A7A4B"/>
+    </a:custClr>
+    <a:custClr name="Kette Lebensende">
+      <a:srgbClr val="85499E"/>
+    </a:custClr>
+    <a:custClr name="Grafik Tinte">
       <a:srgbClr val="29363D"/>
     </a:custClr>
-    <a:custClr name="Kette iron">
-      <a:srgbClr val="8C5A3C"/>
+    <a:custClr name="Grafik leise">
+      <a:srgbClr val="54626A"/>
     </a:custClr>
-    <a:custClr name="Kette steel">
-      <a:srgbClr val="5B7C99"/>
-    </a:custClr>
-    <a:custClr name="Kette car">
-      <a:srgbClr val="3F6B3F"/>
-    </a:custClr>
-    <a:custClr name="Kette body">
-      <a:srgbClr val="0E8388"/>
-    </a:custClr>
-    <a:custClr name="Kette Lebensende">
-      <a:srgbClr val="6B4C6E"/>
+    <a:custClr name="Burgundy Rand">
+      <a:srgbClr val="E3C2CD"/>
     </a:custClr>
     <a:custClr name="Daten A">
       <a:srgbClr val="B060E0"/>

</xml_diff>